<commit_message>
Simplify English in action plan deck
Shorter, plainer wording on every slide and in the speaker notes.

Co-Authored-By: Claude Opus 5.5 <noreply@anthropic.com>
Claude-Session: https://claude.ai/code/session_01FBuHsgfNN7NePtiYw7LpVx
</commit_message>
<xml_diff>
--- a/The_Daily_Cup_Action_Plan.pptx
+++ b/The_Daily_Cup_Action_Plan.pptx
@@ -117,33 +117,33 @@
   <p:extLst>
     <p:ext uri="{521415D9-36F7-43E2-AB2F-B90AF26B5E84}">
       <p14:sectionLst xmlns:p14="http://schemas.microsoft.com/office/powerpoint/2010/main">
-        <p14:section name="Introduction" id="{327f7443-f15a-0814-c817-fc6ab9acd587}">
+        <p14:section name="Introduction" id="{725a7558-1375-2f86-0c98-0e754d436208}">
           <p14:sldIdLst>
             <p14:sldId id="256"/>
             <p14:sldId id="257"/>
           </p14:sldIdLst>
         </p14:section>
-        <p14:section name="Steps 1 to 3" id="{c88da4eb-595a-2a45-4370-0a795f8254b2}">
+        <p14:section name="Steps 1 to 3" id="{398a89fc-1be6-c619-dd89-bc4965c9e911}">
           <p14:sldIdLst>
             <p14:sldId id="258"/>
             <p14:sldId id="259"/>
             <p14:sldId id="260"/>
           </p14:sldIdLst>
         </p14:section>
-        <p14:section name="Steps 4 to 6" id="{fd6bdfd6-f8e4-05e4-7014-c39dc7b6ee93}">
+        <p14:section name="Steps 4 to 6" id="{6da91d95-7696-21e6-03b0-abc5538db8d4}">
           <p14:sldIdLst>
             <p14:sldId id="261"/>
             <p14:sldId id="262"/>
             <p14:sldId id="263"/>
           </p14:sldIdLst>
         </p14:section>
-        <p14:section name="Step 7 and Summary" id="{5e0b7e1d-af14-d093-efa7-66d6f6ef266c}">
+        <p14:section name="Step 7 and Summary" id="{eb320af7-94d6-26ac-f65d-2ccbe8e0a282}">
           <p14:sldIdLst>
             <p14:sldId id="264"/>
             <p14:sldId id="265"/>
           </p14:sldIdLst>
         </p14:section>
-        <p14:section name="Closing" id="{969d480e-d0bd-b497-7c2b-369e5f180c12}">
+        <p14:section name="Closing" id="{ec9870cd-011f-2b1b-2606-0c6f426dd54d}">
           <p14:sldIdLst>
             <p14:sldId id="266"/>
           </p14:sldIdLst>
@@ -553,8 +553,8 @@
             <a:r>
               <a:rPr lang="en-US" dirty="0"/>
               <a:t>Presenter: Rahma Khaled
-"Good morning. We are the team from Pulse Marketing: Rahma Khaled, Aya Reda, Mahmoud Ibrahim and Abader Zarif.
-In our proposal we showed what we will do for The Daily Cup. Today we show exactly how we will make it happen: our action plan for the first month."</a:t>
+"Good morning. We are Pulse Marketing: Rahma, Aya, Mahmoud and Abader.
+Today we show you our plan for the first month with The Daily Cup."</a:t>
             </a:r>
             <a:endParaRPr lang="en-US" dirty="0"/>
           </a:p>
@@ -643,8 +643,7 @@
             <a:r>
               <a:rPr lang="en-US" dirty="0"/>
               <a:t>Presenter: Abader Zarif
-This table puts the whole plan on one page: every task, who owns it, and in which weeks it happens. Each colour is one team member.
-Week 1 is research and the audit, week 2 is creating the content and setting up the ads, week 3 is the launch, and week 4 is publishing, adjusting and the final review. The weekly report runs all 4 weeks.</a:t>
+This is the whole plan on one page: every task, who does it, and when. Each colour is one person.</a:t>
             </a:r>
             <a:endParaRPr lang="en-US" dirty="0"/>
           </a:p>
@@ -733,8 +732,8 @@
             <a:r>
               <a:rPr lang="en-US" dirty="0"/>
               <a:t>Presenter: Abader Zarif
-To sum up: we have 4 clear goals, 11 tasks, a 4-week timeline, one owner for every task, the resources we need, and a weekly system to track and improve the results.
-Approve the plan today, and the work starts in week 1. Let's make it happen! Thank you. We're happy to answer your questions.</a:t>
+So: 4 goals, 11 tasks, 4 weeks, and one team.
+Say yes today, and we start in week 1. Thank you! Any questions?</a:t>
             </a:r>
             <a:endParaRPr lang="en-US" dirty="0"/>
           </a:p>
@@ -823,9 +822,9 @@
             <a:r>
               <a:rPr lang="en-US" dirty="0"/>
               <a:t>Presenter: Rahma Khaled
-Our action plan follows 7 steps. Each of the next slides explains one step:
-1. Define our goals. 2. List the tasks. 3. Set a timeline. 4. Assign responsibilities.
-5. Identify the resources. 6. Monitor and assess progress. 7. Review and adjust.</a:t>
+Our plan has 7 steps.
+We set goals, list the tasks, set a timeline, and give every task an owner.
+Then we get the resources, check the results, and fix what doesn't work.</a:t>
             </a:r>
             <a:endParaRPr lang="en-US" dirty="0"/>
           </a:p>
@@ -914,13 +913,12 @@
             <a:r>
               <a:rPr lang="en-US" dirty="0"/>
               <a:t>Presenter: Rahma Khaled
-Step 1: define the goals. Our goals are SMART: specific, measurable, achievable, relevant and time-bound.
-By the end of month one we want:
-- Awareness: 40,000+ people near the café see The Daily Cup.
-- Community: 500 new Instagram followers.
-- Inquiries: 100+ messages, calls and direction requests.
-- Sales: 10 extra customers every day by week 4.
-We measure every goal every week.</a:t>
+Step 1 is our goals. They are SMART: clear, measurable and with a deadline.
+In month one we want:
+- 40,000 people to see the café.
+- 500 new followers.
+- 100 messages and calls.
+- 10 more customers every day.</a:t>
             </a:r>
             <a:endParaRPr lang="en-US" dirty="0"/>
           </a:p>
@@ -1009,11 +1007,11 @@
             <a:r>
               <a:rPr lang="en-US" dirty="0"/>
               <a:t>Presenter: Aya Reda
-Step 2: list the tasks. We have 11 tasks in 4 groups:
-- Prepare: market and competitor research, define the target audience, and a free audit of the café's pages.
-- Create: the monthly content plan, a photo and video shoot at the café, and designing posts, reels and stories.
-- Launch: set up and launch the Facebook and Instagram ads, publish content and reply to comments, and launch the special offers.
-- Measure: track the KPIs with a weekly report, and the month-one review with the plan for next month.</a:t>
+Step 2 is the tasks. We have 11 tasks in 4 groups:
+- Prepare: study the market, know our customers, and check the café's pages.
+- Create: make a content plan, take photos and videos, and design posts and reels.
+- Launch: start the ads, post and reply, and start the offers.
+- Measure: a weekly report and a final review.</a:t>
             </a:r>
             <a:endParaRPr lang="en-US" dirty="0"/>
           </a:p>
@@ -1102,11 +1100,12 @@
             <a:r>
               <a:rPr lang="en-US" dirty="0"/>
               <a:t>Presenter: Aya Reda
-Step 3: set a timeline. The whole plan takes 4 weeks, and each week ends with a clear deadline:
-- Week 1: market research, target audience, free page audit, and we start the content plan. Deadline: research done.
-- Week 2: finish the content plan, the photo and video shoot, design the content and set up the ads. Deadline: content and ads ready.
-- Week 3: launch the ads, publish and reply, launch the offers. Deadline: the campaign is live.
-- Week 4: keep publishing, adjust the ads, write the final report and do the month-one review. Deadline: review delivered.</a:t>
+Step 3 is the timeline. The plan takes 4 weeks:
+- Week 1: we study the market and check the pages.
+- Week 2: we make the content and prepare the ads.
+- Week 3: the campaign starts.
+- Week 4: we improve the ads and do the final review.
+Every week has a clear deadline.</a:t>
             </a:r>
             <a:endParaRPr lang="en-US" dirty="0"/>
           </a:p>
@@ -1195,11 +1194,11 @@
             <a:r>
               <a:rPr lang="en-US" dirty="0"/>
               <a:t>Presenter: Mahmoud Ibrahim
-Step 4: assign responsibilities. Every task has one clear owner:
-- Rahma Khaled, account manager: market research, target audience, the month-one review, and she is the main contact for the owner.
-- Aya Reda, social media and content: the content plan, publishing and replying, and the special offers.
-- Mahmoud Ibrahim, ads and analytics: the free page audit, the Facebook and Instagram ads, and the KPIs with the weekly report.
-- Abader Zarif, design and photography: the photo and video shoot, and designing the posts, reels and stories.</a:t>
+Step 4 is who does what. Every task has one owner:
+- Rahma is the account manager. She does the market study and the final review.
+- Aya does social media: the content plan, posting and the offers.
+- Mahmoud does the ads and the weekly report.
+- Abader takes the photos and videos and designs the posts.</a:t>
             </a:r>
             <a:endParaRPr lang="en-US" dirty="0"/>
           </a:p>
@@ -1288,10 +1287,10 @@
             <a:r>
               <a:rPr lang="en-US" dirty="0"/>
               <a:t>Presenter: Mahmoud Ibrahim
-Step 5: identify the resources.
-- Budget: 13,000 EGP a month: 5,000 for social media, 4,000 for paid ads, 3,000 for content and 1,000 for reports.
-- Tools: Meta Business Suite to post, Meta Ads Manager for the ads, Canva and CapCut for designs and videos, and Google Sheets for the reports.
-- From The Daily Cup we only need: access to the pages, the menu, prices and offers, a time for the photo shoot, and the weekly sales numbers so we can measure results.</a:t>
+Step 5 is what we need.
+- Money: 13,000 EGP a month.
+- Tools: Meta for posts and ads, Canva and CapCut for design, and Google Sheets for reports.
+- From the café: access to the pages, the menu and prices, time for photos, and the weekly sales.</a:t>
             </a:r>
             <a:endParaRPr lang="en-US" dirty="0"/>
           </a:p>
@@ -1380,13 +1379,8 @@
             <a:r>
               <a:rPr lang="en-US" dirty="0"/>
               <a:t>Presenter: Mahmoud Ibrahim
-Step 6: monitor and assess progress. We track 5 KPIs, each with a target and a tool:
-- Reach: 40,000+, from Meta Ads Manager.
-- New followers: +500, from Instagram Insights.
-- Inquiries: 100+, from the messages and calls log.
-- Cost per inquiry: under 40 EGP, from Meta Ads Manager.
-- Daily customers: +10, from the café's sales records.
-Our rhythm: every day we check the ads, comments and messages; every Sunday the owner gets a progress report; and at the end of week 4 we do a full results review.</a:t>
+Step 6 is checking progress. We watch 5 numbers: reach, followers, messages, cost per message, and new customers.
+Every day we check the ads and comments. Every Sunday we send the owner a report. In week 4 we do the final review.</a:t>
             </a:r>
             <a:endParaRPr lang="en-US" dirty="0"/>
           </a:p>
@@ -1475,12 +1469,12 @@
             <a:r>
               <a:rPr lang="en-US" dirty="0"/>
               <a:t>Presenter: Abader Zarif
-Step 7: review and adjust. We don't wait until the end of the month to fix problems:
-- If reach is below target, we move the budget to the best-performing ad.
-- If there are few likes and comments, we post more reels and test new posting times.
-- If many people see the posts but few send messages, we add a clearer offer and call to action.
-- If there are few new visits, we make the offer stronger and target people closer to the café.
-At the end of the month, we review everything with the owner and plan month two.</a:t>
+Step 7 is review and fix. We don't wait for the end of the month:
+- If few people see us, we put more money in the best ad.
+- If we get few likes, we post more reels.
+- If people watch but don't send messages, we add a clear offer.
+- If few new customers come, we make the offer better.
+At the end of the month, we meet the owner and plan month two.</a:t>
             </a:r>
             <a:endParaRPr lang="en-US" dirty="0"/>
           </a:p>
@@ -2350,7 +2344,7 @@
                   <a:schemeClr val="accent2"/>
                 </a:solidFill>
               </a:rPr>
-              <a:t>Month-one campaign for The Daily Cup Café</a:t>
+              <a:t>Our first month with The Daily Cup</a:t>
             </a:r>
             <a:endParaRPr lang="en-US" sz="1500" dirty="0"/>
           </a:p>
@@ -2658,7 +2652,7 @@
                 <a:ea typeface="Cambria" pitchFamily="34" charset="-122"/>
                 <a:cs typeface="Cambria" pitchFamily="34" charset="-120"/>
               </a:rPr>
-              <a:t>The Action Plan at a Glance</a:t>
+              <a:t>The Whole Plan on One Page</a:t>
             </a:r>
             <a:endParaRPr lang="en-US" sz="3200" dirty="0"/>
           </a:p>
@@ -2687,8 +2681,8 @@
             <a:tbl>
               <a:tblPr/>
               <a:tblGrid>
-                <a:gridCol w="3749040"/>
-                <a:gridCol w="1188720"/>
+                <a:gridCol w="3474720"/>
+                <a:gridCol w="1463040"/>
                 <a:gridCol w="822960"/>
                 <a:gridCol w="822960"/>
                 <a:gridCol w="822960"/>
@@ -2704,14 +2698,14 @@
                         <a:buNone/>
                       </a:pPr>
                       <a:r>
-                        <a:rPr lang="en-US" sz="1200" b="1" dirty="0">
+                        <a:rPr lang="en-US" sz="1300" b="1" dirty="0">
                           <a:solidFill>
                             <a:schemeClr val="bg1"/>
                           </a:solidFill>
                         </a:rPr>
                         <a:t>Task</a:t>
                       </a:r>
-                      <a:endParaRPr lang="en-US" sz="1200" dirty="0"/>
+                      <a:endParaRPr lang="en-US" sz="1300" dirty="0"/>
                     </a:p>
                   </a:txBody>
                   <a:tcPr marL="91440" marR="91440" marT="18288" marB="18288" anchor="ctr">
@@ -2765,14 +2759,14 @@
                         <a:buNone/>
                       </a:pPr>
                       <a:r>
-                        <a:rPr lang="en-US" sz="1200" b="1" dirty="0">
+                        <a:rPr lang="en-US" sz="1300" b="1" dirty="0">
                           <a:solidFill>
                             <a:schemeClr val="bg1"/>
                           </a:solidFill>
                         </a:rPr>
                         <a:t>Owner</a:t>
                       </a:r>
-                      <a:endParaRPr lang="en-US" sz="1200" dirty="0"/>
+                      <a:endParaRPr lang="en-US" sz="1300" dirty="0"/>
                     </a:p>
                   </a:txBody>
                   <a:tcPr marL="91440" marR="91440" marT="18288" marB="18288" anchor="ctr">
@@ -2826,14 +2820,14 @@
                         <a:buNone/>
                       </a:pPr>
                       <a:r>
-                        <a:rPr lang="en-US" sz="1200" b="1" dirty="0">
+                        <a:rPr lang="en-US" sz="1300" b="1" dirty="0">
                           <a:solidFill>
                             <a:schemeClr val="bg1"/>
                           </a:solidFill>
                         </a:rPr>
                         <a:t>Week 1</a:t>
                       </a:r>
-                      <a:endParaRPr lang="en-US" sz="1200" dirty="0"/>
+                      <a:endParaRPr lang="en-US" sz="1300" dirty="0"/>
                     </a:p>
                   </a:txBody>
                   <a:tcPr marL="91440" marR="91440" marT="18288" marB="18288" anchor="ctr">
@@ -2887,14 +2881,14 @@
                         <a:buNone/>
                       </a:pPr>
                       <a:r>
-                        <a:rPr lang="en-US" sz="1200" b="1" dirty="0">
+                        <a:rPr lang="en-US" sz="1300" b="1" dirty="0">
                           <a:solidFill>
                             <a:schemeClr val="bg1"/>
                           </a:solidFill>
                         </a:rPr>
                         <a:t>Week 2</a:t>
                       </a:r>
-                      <a:endParaRPr lang="en-US" sz="1200" dirty="0"/>
+                      <a:endParaRPr lang="en-US" sz="1300" dirty="0"/>
                     </a:p>
                   </a:txBody>
                   <a:tcPr marL="91440" marR="91440" marT="18288" marB="18288" anchor="ctr">
@@ -2948,14 +2942,14 @@
                         <a:buNone/>
                       </a:pPr>
                       <a:r>
-                        <a:rPr lang="en-US" sz="1200" b="1" dirty="0">
+                        <a:rPr lang="en-US" sz="1300" b="1" dirty="0">
                           <a:solidFill>
                             <a:schemeClr val="bg1"/>
                           </a:solidFill>
                         </a:rPr>
                         <a:t>Week 3</a:t>
                       </a:r>
-                      <a:endParaRPr lang="en-US" sz="1200" dirty="0"/>
+                      <a:endParaRPr lang="en-US" sz="1300" dirty="0"/>
                     </a:p>
                   </a:txBody>
                   <a:tcPr marL="91440" marR="91440" marT="18288" marB="18288" anchor="ctr">
@@ -3009,14 +3003,14 @@
                         <a:buNone/>
                       </a:pPr>
                       <a:r>
-                        <a:rPr lang="en-US" sz="1200" b="1" dirty="0">
+                        <a:rPr lang="en-US" sz="1300" b="1" dirty="0">
                           <a:solidFill>
                             <a:schemeClr val="bg1"/>
                           </a:solidFill>
                         </a:rPr>
                         <a:t>Week 4</a:t>
                       </a:r>
-                      <a:endParaRPr lang="en-US" sz="1200" dirty="0"/>
+                      <a:endParaRPr lang="en-US" sz="1300" dirty="0"/>
                     </a:p>
                   </a:txBody>
                   <a:tcPr marL="91440" marR="91440" marT="18288" marB="18288" anchor="ctr">
@@ -3072,14 +3066,14 @@
                         <a:buNone/>
                       </a:pPr>
                       <a:r>
-                        <a:rPr lang="en-US" sz="1200" dirty="0">
+                        <a:rPr lang="en-US" sz="1300" dirty="0">
                           <a:solidFill>
                             <a:schemeClr val="tx1"/>
                           </a:solidFill>
                         </a:rPr>
-                        <a:t>Market and competitor research</a:t>
+                        <a:t>Study the market</a:t>
                       </a:r>
-                      <a:endParaRPr lang="en-US" sz="1200" dirty="0"/>
+                      <a:endParaRPr lang="en-US" sz="1300" dirty="0"/>
                     </a:p>
                   </a:txBody>
                   <a:tcPr marL="91440" marR="91440" marT="18288" marB="18288" anchor="ctr">
@@ -3133,14 +3127,14 @@
                         <a:buNone/>
                       </a:pPr>
                       <a:r>
-                        <a:rPr lang="en-US" sz="1200" b="1" dirty="0">
+                        <a:rPr lang="en-US" sz="1300" b="1" dirty="0">
                           <a:solidFill>
                             <a:schemeClr val="tx2"/>
                           </a:solidFill>
                         </a:rPr>
                         <a:t>Rahma</a:t>
                       </a:r>
-                      <a:endParaRPr lang="en-US" sz="1200" dirty="0"/>
+                      <a:endParaRPr lang="en-US" sz="1300" dirty="0"/>
                     </a:p>
                   </a:txBody>
                   <a:tcPr marL="91440" marR="91440" marT="18288" marB="18288" anchor="ctr">
@@ -3193,7 +3187,7 @@
                       <a:pPr indent="0" marL="0">
                         <a:buNone/>
                       </a:pPr>
-                      <a:endParaRPr lang="en-US" sz="1200" dirty="0"/>
+                      <a:endParaRPr lang="en-US" sz="1300" dirty="0"/>
                     </a:p>
                   </a:txBody>
                   <a:tcPr marL="91440" marR="91440" marT="18288" marB="18288" anchor="ctr">
@@ -3246,7 +3240,7 @@
                       <a:pPr indent="0" marL="0">
                         <a:buNone/>
                       </a:pPr>
-                      <a:endParaRPr lang="en-US" sz="1200" dirty="0"/>
+                      <a:endParaRPr lang="en-US" sz="1300" dirty="0"/>
                     </a:p>
                   </a:txBody>
                   <a:tcPr marL="91440" marR="91440" marT="18288" marB="18288" anchor="ctr">
@@ -3299,7 +3293,7 @@
                       <a:pPr indent="0" marL="0">
                         <a:buNone/>
                       </a:pPr>
-                      <a:endParaRPr lang="en-US" sz="1200" dirty="0"/>
+                      <a:endParaRPr lang="en-US" sz="1300" dirty="0"/>
                     </a:p>
                   </a:txBody>
                   <a:tcPr marL="91440" marR="91440" marT="18288" marB="18288" anchor="ctr">
@@ -3352,7 +3346,7 @@
                       <a:pPr indent="0" marL="0">
                         <a:buNone/>
                       </a:pPr>
-                      <a:endParaRPr lang="en-US" sz="1200" dirty="0"/>
+                      <a:endParaRPr lang="en-US" sz="1300" dirty="0"/>
                     </a:p>
                   </a:txBody>
                   <a:tcPr marL="91440" marR="91440" marT="18288" marB="18288" anchor="ctr">
@@ -3408,14 +3402,14 @@
                         <a:buNone/>
                       </a:pPr>
                       <a:r>
-                        <a:rPr lang="en-US" sz="1200" dirty="0">
+                        <a:rPr lang="en-US" sz="1300" dirty="0">
                           <a:solidFill>
                             <a:schemeClr val="tx1"/>
                           </a:solidFill>
                         </a:rPr>
-                        <a:t>Define the target audience</a:t>
+                        <a:t>Know our customers</a:t>
                       </a:r>
-                      <a:endParaRPr lang="en-US" sz="1200" dirty="0"/>
+                      <a:endParaRPr lang="en-US" sz="1300" dirty="0"/>
                     </a:p>
                   </a:txBody>
                   <a:tcPr marL="91440" marR="91440" marT="18288" marB="18288" anchor="ctr">
@@ -3469,14 +3463,14 @@
                         <a:buNone/>
                       </a:pPr>
                       <a:r>
-                        <a:rPr lang="en-US" sz="1200" b="1" dirty="0">
+                        <a:rPr lang="en-US" sz="1300" b="1" dirty="0">
                           <a:solidFill>
                             <a:schemeClr val="tx2"/>
                           </a:solidFill>
                         </a:rPr>
                         <a:t>Rahma</a:t>
                       </a:r>
-                      <a:endParaRPr lang="en-US" sz="1200" dirty="0"/>
+                      <a:endParaRPr lang="en-US" sz="1300" dirty="0"/>
                     </a:p>
                   </a:txBody>
                   <a:tcPr marL="91440" marR="91440" marT="18288" marB="18288" anchor="ctr">
@@ -3529,7 +3523,7 @@
                       <a:pPr indent="0" marL="0">
                         <a:buNone/>
                       </a:pPr>
-                      <a:endParaRPr lang="en-US" sz="1200" dirty="0"/>
+                      <a:endParaRPr lang="en-US" sz="1300" dirty="0"/>
                     </a:p>
                   </a:txBody>
                   <a:tcPr marL="91440" marR="91440" marT="18288" marB="18288" anchor="ctr">
@@ -3582,7 +3576,7 @@
                       <a:pPr indent="0" marL="0">
                         <a:buNone/>
                       </a:pPr>
-                      <a:endParaRPr lang="en-US" sz="1200" dirty="0"/>
+                      <a:endParaRPr lang="en-US" sz="1300" dirty="0"/>
                     </a:p>
                   </a:txBody>
                   <a:tcPr marL="91440" marR="91440" marT="18288" marB="18288" anchor="ctr">
@@ -3635,7 +3629,7 @@
                       <a:pPr indent="0" marL="0">
                         <a:buNone/>
                       </a:pPr>
-                      <a:endParaRPr lang="en-US" sz="1200" dirty="0"/>
+                      <a:endParaRPr lang="en-US" sz="1300" dirty="0"/>
                     </a:p>
                   </a:txBody>
                   <a:tcPr marL="91440" marR="91440" marT="18288" marB="18288" anchor="ctr">
@@ -3688,7 +3682,7 @@
                       <a:pPr indent="0" marL="0">
                         <a:buNone/>
                       </a:pPr>
-                      <a:endParaRPr lang="en-US" sz="1200" dirty="0"/>
+                      <a:endParaRPr lang="en-US" sz="1300" dirty="0"/>
                     </a:p>
                   </a:txBody>
                   <a:tcPr marL="91440" marR="91440" marT="18288" marB="18288" anchor="ctr">
@@ -3744,14 +3738,14 @@
                         <a:buNone/>
                       </a:pPr>
                       <a:r>
-                        <a:rPr lang="en-US" sz="1200" dirty="0">
+                        <a:rPr lang="en-US" sz="1300" dirty="0">
                           <a:solidFill>
                             <a:schemeClr val="tx1"/>
                           </a:solidFill>
                         </a:rPr>
-                        <a:t>Free audit of the café's pages</a:t>
+                        <a:t>Check the café's pages</a:t>
                       </a:r>
-                      <a:endParaRPr lang="en-US" sz="1200" dirty="0"/>
+                      <a:endParaRPr lang="en-US" sz="1300" dirty="0"/>
                     </a:p>
                   </a:txBody>
                   <a:tcPr marL="91440" marR="91440" marT="18288" marB="18288" anchor="ctr">
@@ -3805,14 +3799,14 @@
                         <a:buNone/>
                       </a:pPr>
                       <a:r>
-                        <a:rPr lang="en-US" sz="1200" b="1" dirty="0">
+                        <a:rPr lang="en-US" sz="1300" b="1" dirty="0">
                           <a:solidFill>
                             <a:schemeClr val="accent4"/>
                           </a:solidFill>
                         </a:rPr>
                         <a:t>Mahmoud</a:t>
                       </a:r>
-                      <a:endParaRPr lang="en-US" sz="1200" dirty="0"/>
+                      <a:endParaRPr lang="en-US" sz="1300" dirty="0"/>
                     </a:p>
                   </a:txBody>
                   <a:tcPr marL="91440" marR="91440" marT="18288" marB="18288" anchor="ctr">
@@ -3865,7 +3859,7 @@
                       <a:pPr indent="0" marL="0">
                         <a:buNone/>
                       </a:pPr>
-                      <a:endParaRPr lang="en-US" sz="1200" dirty="0"/>
+                      <a:endParaRPr lang="en-US" sz="1300" dirty="0"/>
                     </a:p>
                   </a:txBody>
                   <a:tcPr marL="91440" marR="91440" marT="18288" marB="18288" anchor="ctr">
@@ -3918,7 +3912,7 @@
                       <a:pPr indent="0" marL="0">
                         <a:buNone/>
                       </a:pPr>
-                      <a:endParaRPr lang="en-US" sz="1200" dirty="0"/>
+                      <a:endParaRPr lang="en-US" sz="1300" dirty="0"/>
                     </a:p>
                   </a:txBody>
                   <a:tcPr marL="91440" marR="91440" marT="18288" marB="18288" anchor="ctr">
@@ -3971,7 +3965,7 @@
                       <a:pPr indent="0" marL="0">
                         <a:buNone/>
                       </a:pPr>
-                      <a:endParaRPr lang="en-US" sz="1200" dirty="0"/>
+                      <a:endParaRPr lang="en-US" sz="1300" dirty="0"/>
                     </a:p>
                   </a:txBody>
                   <a:tcPr marL="91440" marR="91440" marT="18288" marB="18288" anchor="ctr">
@@ -4024,7 +4018,7 @@
                       <a:pPr indent="0" marL="0">
                         <a:buNone/>
                       </a:pPr>
-                      <a:endParaRPr lang="en-US" sz="1200" dirty="0"/>
+                      <a:endParaRPr lang="en-US" sz="1300" dirty="0"/>
                     </a:p>
                   </a:txBody>
                   <a:tcPr marL="91440" marR="91440" marT="18288" marB="18288" anchor="ctr">
@@ -4080,14 +4074,14 @@
                         <a:buNone/>
                       </a:pPr>
                       <a:r>
-                        <a:rPr lang="en-US" sz="1200" dirty="0">
+                        <a:rPr lang="en-US" sz="1300" dirty="0">
                           <a:solidFill>
                             <a:schemeClr val="tx1"/>
                           </a:solidFill>
                         </a:rPr>
-                        <a:t>Monthly content plan</a:t>
+                        <a:t>Make a content plan</a:t>
                       </a:r>
-                      <a:endParaRPr lang="en-US" sz="1200" dirty="0"/>
+                      <a:endParaRPr lang="en-US" sz="1300" dirty="0"/>
                     </a:p>
                   </a:txBody>
                   <a:tcPr marL="91440" marR="91440" marT="18288" marB="18288" anchor="ctr">
@@ -4141,14 +4135,14 @@
                         <a:buNone/>
                       </a:pPr>
                       <a:r>
-                        <a:rPr lang="en-US" sz="1200" b="1" dirty="0">
+                        <a:rPr lang="en-US" sz="1300" b="1" dirty="0">
                           <a:solidFill>
                             <a:schemeClr val="accent1"/>
                           </a:solidFill>
                         </a:rPr>
                         <a:t>Aya</a:t>
                       </a:r>
-                      <a:endParaRPr lang="en-US" sz="1200" dirty="0"/>
+                      <a:endParaRPr lang="en-US" sz="1300" dirty="0"/>
                     </a:p>
                   </a:txBody>
                   <a:tcPr marL="91440" marR="91440" marT="18288" marB="18288" anchor="ctr">
@@ -4201,7 +4195,7 @@
                       <a:pPr indent="0" marL="0">
                         <a:buNone/>
                       </a:pPr>
-                      <a:endParaRPr lang="en-US" sz="1200" dirty="0"/>
+                      <a:endParaRPr lang="en-US" sz="1300" dirty="0"/>
                     </a:p>
                   </a:txBody>
                   <a:tcPr marL="91440" marR="91440" marT="18288" marB="18288" anchor="ctr">
@@ -4254,7 +4248,7 @@
                       <a:pPr indent="0" marL="0">
                         <a:buNone/>
                       </a:pPr>
-                      <a:endParaRPr lang="en-US" sz="1200" dirty="0"/>
+                      <a:endParaRPr lang="en-US" sz="1300" dirty="0"/>
                     </a:p>
                   </a:txBody>
                   <a:tcPr marL="91440" marR="91440" marT="18288" marB="18288" anchor="ctr">
@@ -4307,7 +4301,7 @@
                       <a:pPr indent="0" marL="0">
                         <a:buNone/>
                       </a:pPr>
-                      <a:endParaRPr lang="en-US" sz="1200" dirty="0"/>
+                      <a:endParaRPr lang="en-US" sz="1300" dirty="0"/>
                     </a:p>
                   </a:txBody>
                   <a:tcPr marL="91440" marR="91440" marT="18288" marB="18288" anchor="ctr">
@@ -4360,7 +4354,7 @@
                       <a:pPr indent="0" marL="0">
                         <a:buNone/>
                       </a:pPr>
-                      <a:endParaRPr lang="en-US" sz="1200" dirty="0"/>
+                      <a:endParaRPr lang="en-US" sz="1300" dirty="0"/>
                     </a:p>
                   </a:txBody>
                   <a:tcPr marL="91440" marR="91440" marT="18288" marB="18288" anchor="ctr">
@@ -4416,14 +4410,14 @@
                         <a:buNone/>
                       </a:pPr>
                       <a:r>
-                        <a:rPr lang="en-US" sz="1200" dirty="0">
+                        <a:rPr lang="en-US" sz="1300" dirty="0">
                           <a:solidFill>
                             <a:schemeClr val="tx1"/>
                           </a:solidFill>
                         </a:rPr>
-                        <a:t>Photo and video shoot at the café</a:t>
+                        <a:t>Take photos and videos</a:t>
                       </a:r>
-                      <a:endParaRPr lang="en-US" sz="1200" dirty="0"/>
+                      <a:endParaRPr lang="en-US" sz="1300" dirty="0"/>
                     </a:p>
                   </a:txBody>
                   <a:tcPr marL="91440" marR="91440" marT="18288" marB="18288" anchor="ctr">
@@ -4477,14 +4471,14 @@
                         <a:buNone/>
                       </a:pPr>
                       <a:r>
-                        <a:rPr lang="en-US" sz="1200" b="1" dirty="0">
+                        <a:rPr lang="en-US" sz="1300" b="1" dirty="0">
                           <a:solidFill>
                             <a:schemeClr val="accent3"/>
                           </a:solidFill>
                         </a:rPr>
                         <a:t>Abader</a:t>
                       </a:r>
-                      <a:endParaRPr lang="en-US" sz="1200" dirty="0"/>
+                      <a:endParaRPr lang="en-US" sz="1300" dirty="0"/>
                     </a:p>
                   </a:txBody>
                   <a:tcPr marL="91440" marR="91440" marT="18288" marB="18288" anchor="ctr">
@@ -4537,7 +4531,7 @@
                       <a:pPr indent="0" marL="0">
                         <a:buNone/>
                       </a:pPr>
-                      <a:endParaRPr lang="en-US" sz="1200" dirty="0"/>
+                      <a:endParaRPr lang="en-US" sz="1300" dirty="0"/>
                     </a:p>
                   </a:txBody>
                   <a:tcPr marL="91440" marR="91440" marT="18288" marB="18288" anchor="ctr">
@@ -4590,7 +4584,7 @@
                       <a:pPr indent="0" marL="0">
                         <a:buNone/>
                       </a:pPr>
-                      <a:endParaRPr lang="en-US" sz="1200" dirty="0"/>
+                      <a:endParaRPr lang="en-US" sz="1300" dirty="0"/>
                     </a:p>
                   </a:txBody>
                   <a:tcPr marL="91440" marR="91440" marT="18288" marB="18288" anchor="ctr">
@@ -4643,7 +4637,7 @@
                       <a:pPr indent="0" marL="0">
                         <a:buNone/>
                       </a:pPr>
-                      <a:endParaRPr lang="en-US" sz="1200" dirty="0"/>
+                      <a:endParaRPr lang="en-US" sz="1300" dirty="0"/>
                     </a:p>
                   </a:txBody>
                   <a:tcPr marL="91440" marR="91440" marT="18288" marB="18288" anchor="ctr">
@@ -4696,7 +4690,7 @@
                       <a:pPr indent="0" marL="0">
                         <a:buNone/>
                       </a:pPr>
-                      <a:endParaRPr lang="en-US" sz="1200" dirty="0"/>
+                      <a:endParaRPr lang="en-US" sz="1300" dirty="0"/>
                     </a:p>
                   </a:txBody>
                   <a:tcPr marL="91440" marR="91440" marT="18288" marB="18288" anchor="ctr">
@@ -4752,14 +4746,14 @@
                         <a:buNone/>
                       </a:pPr>
                       <a:r>
-                        <a:rPr lang="en-US" sz="1200" dirty="0">
+                        <a:rPr lang="en-US" sz="1300" dirty="0">
                           <a:solidFill>
                             <a:schemeClr val="tx1"/>
                           </a:solidFill>
                         </a:rPr>
-                        <a:t>Design posts, reels and stories</a:t>
+                        <a:t>Design posts and reels</a:t>
                       </a:r>
-                      <a:endParaRPr lang="en-US" sz="1200" dirty="0"/>
+                      <a:endParaRPr lang="en-US" sz="1300" dirty="0"/>
                     </a:p>
                   </a:txBody>
                   <a:tcPr marL="91440" marR="91440" marT="18288" marB="18288" anchor="ctr">
@@ -4813,14 +4807,14 @@
                         <a:buNone/>
                       </a:pPr>
                       <a:r>
-                        <a:rPr lang="en-US" sz="1200" b="1" dirty="0">
+                        <a:rPr lang="en-US" sz="1300" b="1" dirty="0">
                           <a:solidFill>
                             <a:schemeClr val="accent3"/>
                           </a:solidFill>
                         </a:rPr>
                         <a:t>Abader</a:t>
                       </a:r>
-                      <a:endParaRPr lang="en-US" sz="1200" dirty="0"/>
+                      <a:endParaRPr lang="en-US" sz="1300" dirty="0"/>
                     </a:p>
                   </a:txBody>
                   <a:tcPr marL="91440" marR="91440" marT="18288" marB="18288" anchor="ctr">
@@ -4873,7 +4867,7 @@
                       <a:pPr indent="0" marL="0">
                         <a:buNone/>
                       </a:pPr>
-                      <a:endParaRPr lang="en-US" sz="1200" dirty="0"/>
+                      <a:endParaRPr lang="en-US" sz="1300" dirty="0"/>
                     </a:p>
                   </a:txBody>
                   <a:tcPr marL="91440" marR="91440" marT="18288" marB="18288" anchor="ctr">
@@ -4926,7 +4920,7 @@
                       <a:pPr indent="0" marL="0">
                         <a:buNone/>
                       </a:pPr>
-                      <a:endParaRPr lang="en-US" sz="1200" dirty="0"/>
+                      <a:endParaRPr lang="en-US" sz="1300" dirty="0"/>
                     </a:p>
                   </a:txBody>
                   <a:tcPr marL="91440" marR="91440" marT="18288" marB="18288" anchor="ctr">
@@ -4979,7 +4973,7 @@
                       <a:pPr indent="0" marL="0">
                         <a:buNone/>
                       </a:pPr>
-                      <a:endParaRPr lang="en-US" sz="1200" dirty="0"/>
+                      <a:endParaRPr lang="en-US" sz="1300" dirty="0"/>
                     </a:p>
                   </a:txBody>
                   <a:tcPr marL="91440" marR="91440" marT="18288" marB="18288" anchor="ctr">
@@ -5032,7 +5026,7 @@
                       <a:pPr indent="0" marL="0">
                         <a:buNone/>
                       </a:pPr>
-                      <a:endParaRPr lang="en-US" sz="1200" dirty="0"/>
+                      <a:endParaRPr lang="en-US" sz="1300" dirty="0"/>
                     </a:p>
                   </a:txBody>
                   <a:tcPr marL="91440" marR="91440" marT="18288" marB="18288" anchor="ctr">
@@ -5088,14 +5082,14 @@
                         <a:buNone/>
                       </a:pPr>
                       <a:r>
-                        <a:rPr lang="en-US" sz="1200" dirty="0">
+                        <a:rPr lang="en-US" sz="1300" dirty="0">
                           <a:solidFill>
                             <a:schemeClr val="tx1"/>
                           </a:solidFill>
                         </a:rPr>
-                        <a:t>Set up and launch Facebook and Instagram ads</a:t>
+                        <a:t>Prepare and start the ads</a:t>
                       </a:r>
-                      <a:endParaRPr lang="en-US" sz="1200" dirty="0"/>
+                      <a:endParaRPr lang="en-US" sz="1300" dirty="0"/>
                     </a:p>
                   </a:txBody>
                   <a:tcPr marL="91440" marR="91440" marT="18288" marB="18288" anchor="ctr">
@@ -5149,14 +5143,14 @@
                         <a:buNone/>
                       </a:pPr>
                       <a:r>
-                        <a:rPr lang="en-US" sz="1200" b="1" dirty="0">
+                        <a:rPr lang="en-US" sz="1300" b="1" dirty="0">
                           <a:solidFill>
                             <a:schemeClr val="accent4"/>
                           </a:solidFill>
                         </a:rPr>
                         <a:t>Mahmoud</a:t>
                       </a:r>
-                      <a:endParaRPr lang="en-US" sz="1200" dirty="0"/>
+                      <a:endParaRPr lang="en-US" sz="1300" dirty="0"/>
                     </a:p>
                   </a:txBody>
                   <a:tcPr marL="91440" marR="91440" marT="18288" marB="18288" anchor="ctr">
@@ -5209,7 +5203,7 @@
                       <a:pPr indent="0" marL="0">
                         <a:buNone/>
                       </a:pPr>
-                      <a:endParaRPr lang="en-US" sz="1200" dirty="0"/>
+                      <a:endParaRPr lang="en-US" sz="1300" dirty="0"/>
                     </a:p>
                   </a:txBody>
                   <a:tcPr marL="91440" marR="91440" marT="18288" marB="18288" anchor="ctr">
@@ -5262,7 +5256,7 @@
                       <a:pPr indent="0" marL="0">
                         <a:buNone/>
                       </a:pPr>
-                      <a:endParaRPr lang="en-US" sz="1200" dirty="0"/>
+                      <a:endParaRPr lang="en-US" sz="1300" dirty="0"/>
                     </a:p>
                   </a:txBody>
                   <a:tcPr marL="91440" marR="91440" marT="18288" marB="18288" anchor="ctr">
@@ -5315,7 +5309,7 @@
                       <a:pPr indent="0" marL="0">
                         <a:buNone/>
                       </a:pPr>
-                      <a:endParaRPr lang="en-US" sz="1200" dirty="0"/>
+                      <a:endParaRPr lang="en-US" sz="1300" dirty="0"/>
                     </a:p>
                   </a:txBody>
                   <a:tcPr marL="91440" marR="91440" marT="18288" marB="18288" anchor="ctr">
@@ -5368,7 +5362,7 @@
                       <a:pPr indent="0" marL="0">
                         <a:buNone/>
                       </a:pPr>
-                      <a:endParaRPr lang="en-US" sz="1200" dirty="0"/>
+                      <a:endParaRPr lang="en-US" sz="1300" dirty="0"/>
                     </a:p>
                   </a:txBody>
                   <a:tcPr marL="91440" marR="91440" marT="18288" marB="18288" anchor="ctr">
@@ -5424,14 +5418,14 @@
                         <a:buNone/>
                       </a:pPr>
                       <a:r>
-                        <a:rPr lang="en-US" sz="1200" dirty="0">
+                        <a:rPr lang="en-US" sz="1300" dirty="0">
                           <a:solidFill>
                             <a:schemeClr val="tx1"/>
                           </a:solidFill>
                         </a:rPr>
-                        <a:t>Publish content and reply to comments</a:t>
+                        <a:t>Post and reply</a:t>
                       </a:r>
-                      <a:endParaRPr lang="en-US" sz="1200" dirty="0"/>
+                      <a:endParaRPr lang="en-US" sz="1300" dirty="0"/>
                     </a:p>
                   </a:txBody>
                   <a:tcPr marL="91440" marR="91440" marT="18288" marB="18288" anchor="ctr">
@@ -5485,14 +5479,14 @@
                         <a:buNone/>
                       </a:pPr>
                       <a:r>
-                        <a:rPr lang="en-US" sz="1200" b="1" dirty="0">
+                        <a:rPr lang="en-US" sz="1300" b="1" dirty="0">
                           <a:solidFill>
                             <a:schemeClr val="accent1"/>
                           </a:solidFill>
                         </a:rPr>
                         <a:t>Aya</a:t>
                       </a:r>
-                      <a:endParaRPr lang="en-US" sz="1200" dirty="0"/>
+                      <a:endParaRPr lang="en-US" sz="1300" dirty="0"/>
                     </a:p>
                   </a:txBody>
                   <a:tcPr marL="91440" marR="91440" marT="18288" marB="18288" anchor="ctr">
@@ -5545,7 +5539,7 @@
                       <a:pPr indent="0" marL="0">
                         <a:buNone/>
                       </a:pPr>
-                      <a:endParaRPr lang="en-US" sz="1200" dirty="0"/>
+                      <a:endParaRPr lang="en-US" sz="1300" dirty="0"/>
                     </a:p>
                   </a:txBody>
                   <a:tcPr marL="91440" marR="91440" marT="18288" marB="18288" anchor="ctr">
@@ -5598,7 +5592,7 @@
                       <a:pPr indent="0" marL="0">
                         <a:buNone/>
                       </a:pPr>
-                      <a:endParaRPr lang="en-US" sz="1200" dirty="0"/>
+                      <a:endParaRPr lang="en-US" sz="1300" dirty="0"/>
                     </a:p>
                   </a:txBody>
                   <a:tcPr marL="91440" marR="91440" marT="18288" marB="18288" anchor="ctr">
@@ -5651,7 +5645,7 @@
                       <a:pPr indent="0" marL="0">
                         <a:buNone/>
                       </a:pPr>
-                      <a:endParaRPr lang="en-US" sz="1200" dirty="0"/>
+                      <a:endParaRPr lang="en-US" sz="1300" dirty="0"/>
                     </a:p>
                   </a:txBody>
                   <a:tcPr marL="91440" marR="91440" marT="18288" marB="18288" anchor="ctr">
@@ -5704,7 +5698,7 @@
                       <a:pPr indent="0" marL="0">
                         <a:buNone/>
                       </a:pPr>
-                      <a:endParaRPr lang="en-US" sz="1200" dirty="0"/>
+                      <a:endParaRPr lang="en-US" sz="1300" dirty="0"/>
                     </a:p>
                   </a:txBody>
                   <a:tcPr marL="91440" marR="91440" marT="18288" marB="18288" anchor="ctr">
@@ -5760,14 +5754,14 @@
                         <a:buNone/>
                       </a:pPr>
                       <a:r>
-                        <a:rPr lang="en-US" sz="1200" dirty="0">
+                        <a:rPr lang="en-US" sz="1300" dirty="0">
                           <a:solidFill>
                             <a:schemeClr val="tx1"/>
                           </a:solidFill>
                         </a:rPr>
-                        <a:t>Launch the special offers</a:t>
+                        <a:t>Start the offers</a:t>
                       </a:r>
-                      <a:endParaRPr lang="en-US" sz="1200" dirty="0"/>
+                      <a:endParaRPr lang="en-US" sz="1300" dirty="0"/>
                     </a:p>
                   </a:txBody>
                   <a:tcPr marL="91440" marR="91440" marT="18288" marB="18288" anchor="ctr">
@@ -5821,14 +5815,14 @@
                         <a:buNone/>
                       </a:pPr>
                       <a:r>
-                        <a:rPr lang="en-US" sz="1200" b="1" dirty="0">
+                        <a:rPr lang="en-US" sz="1300" b="1" dirty="0">
                           <a:solidFill>
                             <a:schemeClr val="accent1"/>
                           </a:solidFill>
                         </a:rPr>
                         <a:t>Aya</a:t>
                       </a:r>
-                      <a:endParaRPr lang="en-US" sz="1200" dirty="0"/>
+                      <a:endParaRPr lang="en-US" sz="1300" dirty="0"/>
                     </a:p>
                   </a:txBody>
                   <a:tcPr marL="91440" marR="91440" marT="18288" marB="18288" anchor="ctr">
@@ -5881,7 +5875,7 @@
                       <a:pPr indent="0" marL="0">
                         <a:buNone/>
                       </a:pPr>
-                      <a:endParaRPr lang="en-US" sz="1200" dirty="0"/>
+                      <a:endParaRPr lang="en-US" sz="1300" dirty="0"/>
                     </a:p>
                   </a:txBody>
                   <a:tcPr marL="91440" marR="91440" marT="18288" marB="18288" anchor="ctr">
@@ -5934,7 +5928,7 @@
                       <a:pPr indent="0" marL="0">
                         <a:buNone/>
                       </a:pPr>
-                      <a:endParaRPr lang="en-US" sz="1200" dirty="0"/>
+                      <a:endParaRPr lang="en-US" sz="1300" dirty="0"/>
                     </a:p>
                   </a:txBody>
                   <a:tcPr marL="91440" marR="91440" marT="18288" marB="18288" anchor="ctr">
@@ -5987,7 +5981,7 @@
                       <a:pPr indent="0" marL="0">
                         <a:buNone/>
                       </a:pPr>
-                      <a:endParaRPr lang="en-US" sz="1200" dirty="0"/>
+                      <a:endParaRPr lang="en-US" sz="1300" dirty="0"/>
                     </a:p>
                   </a:txBody>
                   <a:tcPr marL="91440" marR="91440" marT="18288" marB="18288" anchor="ctr">
@@ -6040,7 +6034,7 @@
                       <a:pPr indent="0" marL="0">
                         <a:buNone/>
                       </a:pPr>
-                      <a:endParaRPr lang="en-US" sz="1200" dirty="0"/>
+                      <a:endParaRPr lang="en-US" sz="1300" dirty="0"/>
                     </a:p>
                   </a:txBody>
                   <a:tcPr marL="91440" marR="91440" marT="18288" marB="18288" anchor="ctr">
@@ -6096,14 +6090,14 @@
                         <a:buNone/>
                       </a:pPr>
                       <a:r>
-                        <a:rPr lang="en-US" sz="1200" dirty="0">
+                        <a:rPr lang="en-US" sz="1300" dirty="0">
                           <a:solidFill>
                             <a:schemeClr val="tx1"/>
                           </a:solidFill>
                         </a:rPr>
-                        <a:t>Track KPIs and send the weekly report</a:t>
+                        <a:t>Weekly report</a:t>
                       </a:r>
-                      <a:endParaRPr lang="en-US" sz="1200" dirty="0"/>
+                      <a:endParaRPr lang="en-US" sz="1300" dirty="0"/>
                     </a:p>
                   </a:txBody>
                   <a:tcPr marL="91440" marR="91440" marT="18288" marB="18288" anchor="ctr">
@@ -6157,14 +6151,14 @@
                         <a:buNone/>
                       </a:pPr>
                       <a:r>
-                        <a:rPr lang="en-US" sz="1200" b="1" dirty="0">
+                        <a:rPr lang="en-US" sz="1300" b="1" dirty="0">
                           <a:solidFill>
                             <a:schemeClr val="accent4"/>
                           </a:solidFill>
                         </a:rPr>
                         <a:t>Mahmoud</a:t>
                       </a:r>
-                      <a:endParaRPr lang="en-US" sz="1200" dirty="0"/>
+                      <a:endParaRPr lang="en-US" sz="1300" dirty="0"/>
                     </a:p>
                   </a:txBody>
                   <a:tcPr marL="91440" marR="91440" marT="18288" marB="18288" anchor="ctr">
@@ -6217,7 +6211,7 @@
                       <a:pPr indent="0" marL="0">
                         <a:buNone/>
                       </a:pPr>
-                      <a:endParaRPr lang="en-US" sz="1200" dirty="0"/>
+                      <a:endParaRPr lang="en-US" sz="1300" dirty="0"/>
                     </a:p>
                   </a:txBody>
                   <a:tcPr marL="91440" marR="91440" marT="18288" marB="18288" anchor="ctr">
@@ -6270,7 +6264,7 @@
                       <a:pPr indent="0" marL="0">
                         <a:buNone/>
                       </a:pPr>
-                      <a:endParaRPr lang="en-US" sz="1200" dirty="0"/>
+                      <a:endParaRPr lang="en-US" sz="1300" dirty="0"/>
                     </a:p>
                   </a:txBody>
                   <a:tcPr marL="91440" marR="91440" marT="18288" marB="18288" anchor="ctr">
@@ -6323,7 +6317,7 @@
                       <a:pPr indent="0" marL="0">
                         <a:buNone/>
                       </a:pPr>
-                      <a:endParaRPr lang="en-US" sz="1200" dirty="0"/>
+                      <a:endParaRPr lang="en-US" sz="1300" dirty="0"/>
                     </a:p>
                   </a:txBody>
                   <a:tcPr marL="91440" marR="91440" marT="18288" marB="18288" anchor="ctr">
@@ -6376,7 +6370,7 @@
                       <a:pPr indent="0" marL="0">
                         <a:buNone/>
                       </a:pPr>
-                      <a:endParaRPr lang="en-US" sz="1200" dirty="0"/>
+                      <a:endParaRPr lang="en-US" sz="1300" dirty="0"/>
                     </a:p>
                   </a:txBody>
                   <a:tcPr marL="91440" marR="91440" marT="18288" marB="18288" anchor="ctr">
@@ -6432,14 +6426,14 @@
                         <a:buNone/>
                       </a:pPr>
                       <a:r>
-                        <a:rPr lang="en-US" sz="1200" dirty="0">
+                        <a:rPr lang="en-US" sz="1300" dirty="0">
                           <a:solidFill>
                             <a:schemeClr val="tx1"/>
                           </a:solidFill>
                         </a:rPr>
-                        <a:t>Month-one review and next month's plan</a:t>
+                        <a:t>Final review</a:t>
                       </a:r>
-                      <a:endParaRPr lang="en-US" sz="1200" dirty="0"/>
+                      <a:endParaRPr lang="en-US" sz="1300" dirty="0"/>
                     </a:p>
                   </a:txBody>
                   <a:tcPr marL="91440" marR="91440" marT="18288" marB="18288" anchor="ctr">
@@ -6493,14 +6487,14 @@
                         <a:buNone/>
                       </a:pPr>
                       <a:r>
-                        <a:rPr lang="en-US" sz="1200" b="1" dirty="0">
+                        <a:rPr lang="en-US" sz="1300" b="1" dirty="0">
                           <a:solidFill>
                             <a:schemeClr val="tx2"/>
                           </a:solidFill>
                         </a:rPr>
                         <a:t>Rahma</a:t>
                       </a:r>
-                      <a:endParaRPr lang="en-US" sz="1200" dirty="0"/>
+                      <a:endParaRPr lang="en-US" sz="1300" dirty="0"/>
                     </a:p>
                   </a:txBody>
                   <a:tcPr marL="91440" marR="91440" marT="18288" marB="18288" anchor="ctr">
@@ -6553,7 +6547,7 @@
                       <a:pPr indent="0" marL="0">
                         <a:buNone/>
                       </a:pPr>
-                      <a:endParaRPr lang="en-US" sz="1200" dirty="0"/>
+                      <a:endParaRPr lang="en-US" sz="1300" dirty="0"/>
                     </a:p>
                   </a:txBody>
                   <a:tcPr marL="91440" marR="91440" marT="18288" marB="18288" anchor="ctr">
@@ -6606,7 +6600,7 @@
                       <a:pPr indent="0" marL="0">
                         <a:buNone/>
                       </a:pPr>
-                      <a:endParaRPr lang="en-US" sz="1200" dirty="0"/>
+                      <a:endParaRPr lang="en-US" sz="1300" dirty="0"/>
                     </a:p>
                   </a:txBody>
                   <a:tcPr marL="91440" marR="91440" marT="18288" marB="18288" anchor="ctr">
@@ -6659,7 +6653,7 @@
                       <a:pPr indent="0" marL="0">
                         <a:buNone/>
                       </a:pPr>
-                      <a:endParaRPr lang="en-US" sz="1200" dirty="0"/>
+                      <a:endParaRPr lang="en-US" sz="1300" dirty="0"/>
                     </a:p>
                   </a:txBody>
                   <a:tcPr marL="91440" marR="91440" marT="18288" marB="18288" anchor="ctr">
@@ -6712,7 +6706,7 @@
                       <a:pPr indent="0" marL="0">
                         <a:buNone/>
                       </a:pPr>
-                      <a:endParaRPr lang="en-US" sz="1200" dirty="0"/>
+                      <a:endParaRPr lang="en-US" sz="1300" dirty="0"/>
                     </a:p>
                   </a:txBody>
                   <a:tcPr marL="91440" marR="91440" marT="18288" marB="18288" anchor="ctr">
@@ -6943,7 +6937,7 @@
                   <a:schemeClr val="accent2"/>
                 </a:solidFill>
               </a:rPr>
-              <a:t>Approve the plan today, and work starts in week 1.</a:t>
+              <a:t>Say yes today, and we start in week 1.</a:t>
             </a:r>
             <a:endParaRPr lang="en-US" sz="1500" dirty="0"/>
           </a:p>
@@ -7107,7 +7101,7 @@
                 <a:ea typeface="Cambria" pitchFamily="34" charset="-122"/>
                 <a:cs typeface="Cambria" pitchFamily="34" charset="-120"/>
               </a:rPr>
-              <a:t>7 Steps to Make the Plan Happen</a:t>
+              <a:t>Our Plan in 7 Steps</a:t>
             </a:r>
             <a:endParaRPr lang="en-US" sz="3200" dirty="0"/>
           </a:p>
@@ -7274,14 +7268,14 @@
               <a:buNone/>
             </a:pPr>
             <a:r>
-              <a:rPr lang="en-US" sz="1300" dirty="0">
+              <a:rPr lang="en-US" sz="1400" dirty="0">
                 <a:solidFill>
                   <a:schemeClr val="tx1"/>
                 </a:solidFill>
               </a:rPr>
-              <a:t>40K reach, +500 followers, 100+ inquiries, +10 customers a day</a:t>
-            </a:r>
-            <a:endParaRPr lang="en-US" sz="1300" dirty="0"/>
+              <a:t>4 clear goals for month one</a:t>
+            </a:r>
+            <a:endParaRPr lang="en-US" sz="1400" dirty="0"/>
           </a:p>
         </p:txBody>
       </p:sp>
@@ -7446,14 +7440,14 @@
               <a:buNone/>
             </a:pPr>
             <a:r>
-              <a:rPr lang="en-US" sz="1300" dirty="0">
+              <a:rPr lang="en-US" sz="1400" dirty="0">
                 <a:solidFill>
                   <a:schemeClr val="tx1"/>
                 </a:solidFill>
               </a:rPr>
-              <a:t>11 key tasks, from market research to the final review</a:t>
-            </a:r>
-            <a:endParaRPr lang="en-US" sz="1300" dirty="0"/>
+              <a:t>11 tasks</a:t>
+            </a:r>
+            <a:endParaRPr lang="en-US" sz="1400" dirty="0"/>
           </a:p>
         </p:txBody>
       </p:sp>
@@ -7618,14 +7612,14 @@
               <a:buNone/>
             </a:pPr>
             <a:r>
-              <a:rPr lang="en-US" sz="1300" dirty="0">
+              <a:rPr lang="en-US" sz="1400" dirty="0">
                 <a:solidFill>
                   <a:schemeClr val="tx1"/>
                 </a:solidFill>
               </a:rPr>
-              <a:t>4 weeks, with a clear deadline for every week</a:t>
-            </a:r>
-            <a:endParaRPr lang="en-US" sz="1300" dirty="0"/>
+              <a:t>4 weeks</a:t>
+            </a:r>
+            <a:endParaRPr lang="en-US" sz="1400" dirty="0"/>
           </a:p>
         </p:txBody>
       </p:sp>
@@ -7790,14 +7784,14 @@
               <a:buNone/>
             </a:pPr>
             <a:r>
-              <a:rPr lang="en-US" sz="1300" dirty="0">
+              <a:rPr lang="en-US" sz="1400" dirty="0">
                 <a:solidFill>
                   <a:schemeClr val="tx1"/>
                 </a:solidFill>
               </a:rPr>
-              <a:t>Every task has one owner from our team</a:t>
-            </a:r>
-            <a:endParaRPr lang="en-US" sz="1300" dirty="0"/>
+              <a:t>Each task has one owner</a:t>
+            </a:r>
+            <a:endParaRPr lang="en-US" sz="1400" dirty="0"/>
           </a:p>
         </p:txBody>
       </p:sp>
@@ -7962,14 +7956,14 @@
               <a:buNone/>
             </a:pPr>
             <a:r>
-              <a:rPr lang="en-US" sz="1300" dirty="0">
+              <a:rPr lang="en-US" sz="1400" dirty="0">
                 <a:solidFill>
                   <a:schemeClr val="tx1"/>
                 </a:solidFill>
               </a:rPr>
-              <a:t>13,000 EGP budget, the right tools and the café's support</a:t>
-            </a:r>
-            <a:endParaRPr lang="en-US" sz="1300" dirty="0"/>
+              <a:t>Money, tools and the café's help</a:t>
+            </a:r>
+            <a:endParaRPr lang="en-US" sz="1400" dirty="0"/>
           </a:p>
         </p:txBody>
       </p:sp>
@@ -8134,14 +8128,14 @@
               <a:buNone/>
             </a:pPr>
             <a:r>
-              <a:rPr lang="en-US" sz="1300" dirty="0">
+              <a:rPr lang="en-US" sz="1400" dirty="0">
                 <a:solidFill>
                   <a:schemeClr val="tx1"/>
                 </a:solidFill>
               </a:rPr>
-              <a:t>We track 5 KPIs and send a report every Sunday</a:t>
-            </a:r>
-            <a:endParaRPr lang="en-US" sz="1300" dirty="0"/>
+              <a:t>We check the results every week</a:t>
+            </a:r>
+            <a:endParaRPr lang="en-US" sz="1400" dirty="0"/>
           </a:p>
         </p:txBody>
       </p:sp>
@@ -8306,14 +8300,14 @@
               <a:buNone/>
             </a:pPr>
             <a:r>
-              <a:rPr lang="en-US" sz="1300" dirty="0">
+              <a:rPr lang="en-US" sz="1400" dirty="0">
                 <a:solidFill>
                   <a:schemeClr val="tx1"/>
                 </a:solidFill>
               </a:rPr>
-              <a:t>Fix what's weak every week, full review at month end</a:t>
-            </a:r>
-            <a:endParaRPr lang="en-US" sz="1300" dirty="0"/>
+              <a:t>We fix what doesn't work</a:t>
+            </a:r>
+            <a:endParaRPr lang="en-US" sz="1400" dirty="0"/>
           </a:p>
         </p:txBody>
       </p:sp>
@@ -8460,7 +8454,7 @@
                 <a:ea typeface="Cambria" pitchFamily="34" charset="-122"/>
                 <a:cs typeface="Cambria" pitchFamily="34" charset="-120"/>
               </a:rPr>
-              <a:t>Our SMART Goals for Month One</a:t>
+              <a:t>Our Goals for Month One</a:t>
             </a:r>
             <a:endParaRPr lang="en-US" sz="3200" dirty="0"/>
           </a:p>
@@ -9045,7 +9039,7 @@
         <p:spPr>
           <a:xfrm>
             <a:off x="457200" y="1965960"/>
-            <a:ext cx="1920240" cy="2331720"/>
+            <a:ext cx="1920240" cy="2240280"/>
           </a:xfrm>
           <a:prstGeom prst="roundRect">
             <a:avLst>
@@ -9060,7 +9054,7 @@
       </p:sp>
       <p:sp>
         <p:nvSpPr>
-          <p:cNvPr id="25" name="Awareness circle"/>
+          <p:cNvPr id="25" name="Reach circle"/>
           <p:cNvSpPr/>
           <p:nvPr/>
         </p:nvSpPr>
@@ -9080,7 +9074,7 @@
       </p:sp>
       <p:pic>
         <p:nvPicPr>
-          <p:cNvPr id="26" name="Awareness icon" descr="Awareness">    </p:cNvPr>
+          <p:cNvPr id="26" name="Reach icon" descr="Reach">    </p:cNvPr>
           <p:cNvPicPr>
             <a:picLocks noChangeAspect="1"/>
           </p:cNvPicPr>
@@ -9132,7 +9126,7 @@
                   <a:schemeClr val="accent1"/>
                 </a:solidFill>
               </a:rPr>
-              <a:t>AWARENESS</a:t>
+              <a:t>REACH</a:t>
             </a:r>
             <a:endParaRPr lang="en-US" sz="1100" dirty="0"/>
           </a:p>
@@ -9186,7 +9180,7 @@
         <p:spPr>
           <a:xfrm>
             <a:off x="640080" y="3383280"/>
-            <a:ext cx="1600200" cy="777240"/>
+            <a:ext cx="1600200" cy="640080"/>
           </a:xfrm>
           <a:prstGeom prst="rect">
             <a:avLst/>
@@ -9202,14 +9196,14 @@
               <a:buNone/>
             </a:pPr>
             <a:r>
-              <a:rPr lang="en-US" sz="1300" dirty="0">
+              <a:rPr lang="en-US" sz="1400" dirty="0">
                 <a:solidFill>
                   <a:schemeClr val="tx1"/>
                 </a:solidFill>
               </a:rPr>
-              <a:t>people nearby see The Daily Cup</a:t>
-            </a:r>
-            <a:endParaRPr lang="en-US" sz="1300" dirty="0"/>
+              <a:t>people see the café</a:t>
+            </a:r>
+            <a:endParaRPr lang="en-US" sz="1400" dirty="0"/>
           </a:p>
         </p:txBody>
       </p:sp>
@@ -9222,7 +9216,7 @@
         <p:spPr>
           <a:xfrm>
             <a:off x="2560320" y="1965960"/>
-            <a:ext cx="1920240" cy="2331720"/>
+            <a:ext cx="1920240" cy="2240280"/>
           </a:xfrm>
           <a:prstGeom prst="roundRect">
             <a:avLst>
@@ -9237,7 +9231,7 @@
       </p:sp>
       <p:sp>
         <p:nvSpPr>
-          <p:cNvPr id="31" name="Community circle"/>
+          <p:cNvPr id="31" name="Followers circle"/>
           <p:cNvSpPr/>
           <p:nvPr/>
         </p:nvSpPr>
@@ -9257,7 +9251,7 @@
       </p:sp>
       <p:pic>
         <p:nvPicPr>
-          <p:cNvPr id="32" name="Community icon" descr="Community">    </p:cNvPr>
+          <p:cNvPr id="32" name="Followers icon" descr="Followers">    </p:cNvPr>
           <p:cNvPicPr>
             <a:picLocks noChangeAspect="1"/>
           </p:cNvPicPr>
@@ -9309,7 +9303,7 @@
                   <a:schemeClr val="accent1"/>
                 </a:solidFill>
               </a:rPr>
-              <a:t>COMMUNITY</a:t>
+              <a:t>FOLLOWERS</a:t>
             </a:r>
             <a:endParaRPr lang="en-US" sz="1100" dirty="0"/>
           </a:p>
@@ -9363,7 +9357,7 @@
         <p:spPr>
           <a:xfrm>
             <a:off x="2743200" y="3383280"/>
-            <a:ext cx="1600200" cy="777240"/>
+            <a:ext cx="1600200" cy="640080"/>
           </a:xfrm>
           <a:prstGeom prst="rect">
             <a:avLst/>
@@ -9379,14 +9373,14 @@
               <a:buNone/>
             </a:pPr>
             <a:r>
-              <a:rPr lang="en-US" sz="1300" dirty="0">
+              <a:rPr lang="en-US" sz="1400" dirty="0">
                 <a:solidFill>
                   <a:schemeClr val="tx1"/>
                 </a:solidFill>
               </a:rPr>
-              <a:t>new Instagram followers</a:t>
-            </a:r>
-            <a:endParaRPr lang="en-US" sz="1300" dirty="0"/>
+              <a:t>new followers</a:t>
+            </a:r>
+            <a:endParaRPr lang="en-US" sz="1400" dirty="0"/>
           </a:p>
         </p:txBody>
       </p:sp>
@@ -9399,7 +9393,7 @@
         <p:spPr>
           <a:xfrm>
             <a:off x="4663440" y="1965960"/>
-            <a:ext cx="1920240" cy="2331720"/>
+            <a:ext cx="1920240" cy="2240280"/>
           </a:xfrm>
           <a:prstGeom prst="roundRect">
             <a:avLst>
@@ -9414,7 +9408,7 @@
       </p:sp>
       <p:sp>
         <p:nvSpPr>
-          <p:cNvPr id="37" name="Inquiries circle"/>
+          <p:cNvPr id="37" name="Messages circle"/>
           <p:cNvSpPr/>
           <p:nvPr/>
         </p:nvSpPr>
@@ -9434,7 +9428,7 @@
       </p:sp>
       <p:pic>
         <p:nvPicPr>
-          <p:cNvPr id="38" name="Inquiries icon" descr="Inquiries">    </p:cNvPr>
+          <p:cNvPr id="38" name="Messages icon" descr="Messages">    </p:cNvPr>
           <p:cNvPicPr>
             <a:picLocks noChangeAspect="1"/>
           </p:cNvPicPr>
@@ -9486,7 +9480,7 @@
                   <a:schemeClr val="accent1"/>
                 </a:solidFill>
               </a:rPr>
-              <a:t>INQUIRIES</a:t>
+              <a:t>MESSAGES</a:t>
             </a:r>
             <a:endParaRPr lang="en-US" sz="1100" dirty="0"/>
           </a:p>
@@ -9540,7 +9534,7 @@
         <p:spPr>
           <a:xfrm>
             <a:off x="4846320" y="3383280"/>
-            <a:ext cx="1600200" cy="777240"/>
+            <a:ext cx="1600200" cy="640080"/>
           </a:xfrm>
           <a:prstGeom prst="rect">
             <a:avLst/>
@@ -9556,14 +9550,14 @@
               <a:buNone/>
             </a:pPr>
             <a:r>
-              <a:rPr lang="en-US" sz="1300" dirty="0">
+              <a:rPr lang="en-US" sz="1400" dirty="0">
                 <a:solidFill>
                   <a:schemeClr val="tx1"/>
                 </a:solidFill>
               </a:rPr>
-              <a:t>messages, calls and direction requests</a:t>
-            </a:r>
-            <a:endParaRPr lang="en-US" sz="1300" dirty="0"/>
+              <a:t>messages and calls</a:t>
+            </a:r>
+            <a:endParaRPr lang="en-US" sz="1400" dirty="0"/>
           </a:p>
         </p:txBody>
       </p:sp>
@@ -9576,7 +9570,7 @@
         <p:spPr>
           <a:xfrm>
             <a:off x="6766560" y="1965960"/>
-            <a:ext cx="1920240" cy="2331720"/>
+            <a:ext cx="1920240" cy="2240280"/>
           </a:xfrm>
           <a:prstGeom prst="roundRect">
             <a:avLst>
@@ -9591,7 +9585,7 @@
       </p:sp>
       <p:sp>
         <p:nvSpPr>
-          <p:cNvPr id="43" name="Sales circle"/>
+          <p:cNvPr id="43" name="Customers circle"/>
           <p:cNvSpPr/>
           <p:nvPr/>
         </p:nvSpPr>
@@ -9611,7 +9605,7 @@
       </p:sp>
       <p:pic>
         <p:nvPicPr>
-          <p:cNvPr id="44" name="Sales icon" descr="Sales">    </p:cNvPr>
+          <p:cNvPr id="44" name="Customers icon" descr="Customers">    </p:cNvPr>
           <p:cNvPicPr>
             <a:picLocks noChangeAspect="1"/>
           </p:cNvPicPr>
@@ -9663,7 +9657,7 @@
                   <a:schemeClr val="bg1"/>
                 </a:solidFill>
               </a:rPr>
-              <a:t>SALES</a:t>
+              <a:t>CUSTOMERS</a:t>
             </a:r>
             <a:endParaRPr lang="en-US" sz="1100" dirty="0"/>
           </a:p>
@@ -9717,7 +9711,7 @@
         <p:spPr>
           <a:xfrm>
             <a:off x="6949440" y="3383280"/>
-            <a:ext cx="1600200" cy="777240"/>
+            <a:ext cx="1600200" cy="640080"/>
           </a:xfrm>
           <a:prstGeom prst="rect">
             <a:avLst/>
@@ -9733,14 +9727,14 @@
               <a:buNone/>
             </a:pPr>
             <a:r>
-              <a:rPr lang="en-US" sz="1300" dirty="0">
+              <a:rPr lang="en-US" sz="1400" dirty="0">
                 <a:solidFill>
                   <a:schemeClr val="bg1"/>
                 </a:solidFill>
               </a:rPr>
-              <a:t>extra customers a day by week 4</a:t>
-            </a:r>
-            <a:endParaRPr lang="en-US" sz="1300" dirty="0"/>
+              <a:t>more customers a day</a:t>
+            </a:r>
+            <a:endParaRPr lang="en-US" sz="1400" dirty="0"/>
           </a:p>
         </p:txBody>
       </p:sp>
@@ -9752,7 +9746,7 @@
         </p:nvSpPr>
         <p:spPr>
           <a:xfrm>
-            <a:off x="457200" y="4389120"/>
+            <a:off x="457200" y="4343400"/>
             <a:ext cx="8229600" cy="274320"/>
           </a:xfrm>
           <a:prstGeom prst="rect">
@@ -9769,14 +9763,14 @@
               <a:buNone/>
             </a:pPr>
             <a:r>
-              <a:rPr lang="en-US" sz="1100" i="1" dirty="0">
+              <a:rPr lang="en-US" sz="1200" i="1" dirty="0">
                 <a:solidFill>
                   <a:schemeClr val="accent5"/>
                 </a:solidFill>
               </a:rPr>
-              <a:t>All goals are measured every week and due by the end of week 4.</a:t>
-            </a:r>
-            <a:endParaRPr lang="en-US" sz="1100" dirty="0"/>
+              <a:t>We check these goals every week.</a:t>
+            </a:r>
+            <a:endParaRPr lang="en-US" sz="1200" dirty="0"/>
           </a:p>
         </p:txBody>
       </p:sp>
@@ -10097,14 +10091,14 @@
               <a:buNone/>
             </a:pPr>
             <a:r>
-              <a:rPr lang="en-US" sz="1200" dirty="0">
+              <a:rPr lang="en-US" sz="1300" dirty="0">
                 <a:solidFill>
                   <a:schemeClr val="tx1"/>
                 </a:solidFill>
               </a:rPr>
-              <a:t>Market and competitor research</a:t>
-            </a:r>
-            <a:endParaRPr lang="en-US" sz="1200" dirty="0"/>
+              <a:t>Study the market</a:t>
+            </a:r>
+            <a:endParaRPr lang="en-US" sz="1300" dirty="0"/>
           </a:p>
         </p:txBody>
       </p:sp>
@@ -10194,14 +10188,14 @@
               <a:buNone/>
             </a:pPr>
             <a:r>
-              <a:rPr lang="en-US" sz="1200" dirty="0">
+              <a:rPr lang="en-US" sz="1300" dirty="0">
                 <a:solidFill>
                   <a:schemeClr val="tx1"/>
                 </a:solidFill>
               </a:rPr>
-              <a:t>Define the target audience</a:t>
-            </a:r>
-            <a:endParaRPr lang="en-US" sz="1200" dirty="0"/>
+              <a:t>Know our customers</a:t>
+            </a:r>
+            <a:endParaRPr lang="en-US" sz="1300" dirty="0"/>
           </a:p>
         </p:txBody>
       </p:sp>
@@ -10291,14 +10285,14 @@
               <a:buNone/>
             </a:pPr>
             <a:r>
-              <a:rPr lang="en-US" sz="1200" dirty="0">
+              <a:rPr lang="en-US" sz="1300" dirty="0">
                 <a:solidFill>
                   <a:schemeClr val="tx1"/>
                 </a:solidFill>
               </a:rPr>
-              <a:t>Free audit of the café's pages</a:t>
-            </a:r>
-            <a:endParaRPr lang="en-US" sz="1200" dirty="0"/>
+              <a:t>Check the café's pages</a:t>
+            </a:r>
+            <a:endParaRPr lang="en-US" sz="1300" dirty="0"/>
           </a:p>
         </p:txBody>
       </p:sp>
@@ -10470,14 +10464,14 @@
               <a:buNone/>
             </a:pPr>
             <a:r>
-              <a:rPr lang="en-US" sz="1200" dirty="0">
+              <a:rPr lang="en-US" sz="1300" dirty="0">
                 <a:solidFill>
                   <a:schemeClr val="tx1"/>
                 </a:solidFill>
               </a:rPr>
-              <a:t>Monthly content plan</a:t>
-            </a:r>
-            <a:endParaRPr lang="en-US" sz="1200" dirty="0"/>
+              <a:t>Make a content plan</a:t>
+            </a:r>
+            <a:endParaRPr lang="en-US" sz="1300" dirty="0"/>
           </a:p>
         </p:txBody>
       </p:sp>
@@ -10567,14 +10561,14 @@
               <a:buNone/>
             </a:pPr>
             <a:r>
-              <a:rPr lang="en-US" sz="1200" dirty="0">
+              <a:rPr lang="en-US" sz="1300" dirty="0">
                 <a:solidFill>
                   <a:schemeClr val="tx1"/>
                 </a:solidFill>
               </a:rPr>
-              <a:t>Photo and video shoot</a:t>
-            </a:r>
-            <a:endParaRPr lang="en-US" sz="1200" dirty="0"/>
+              <a:t>Take photos and videos</a:t>
+            </a:r>
+            <a:endParaRPr lang="en-US" sz="1300" dirty="0"/>
           </a:p>
         </p:txBody>
       </p:sp>
@@ -10664,14 +10658,14 @@
               <a:buNone/>
             </a:pPr>
             <a:r>
-              <a:rPr lang="en-US" sz="1200" dirty="0">
+              <a:rPr lang="en-US" sz="1300" dirty="0">
                 <a:solidFill>
                   <a:schemeClr val="tx1"/>
                 </a:solidFill>
               </a:rPr>
-              <a:t>Design posts, reels and stories</a:t>
-            </a:r>
-            <a:endParaRPr lang="en-US" sz="1200" dirty="0"/>
+              <a:t>Design posts and reels</a:t>
+            </a:r>
+            <a:endParaRPr lang="en-US" sz="1300" dirty="0"/>
           </a:p>
         </p:txBody>
       </p:sp>
@@ -10843,14 +10837,14 @@
               <a:buNone/>
             </a:pPr>
             <a:r>
-              <a:rPr lang="en-US" sz="1200" dirty="0">
+              <a:rPr lang="en-US" sz="1300" dirty="0">
                 <a:solidFill>
                   <a:schemeClr val="tx1"/>
                 </a:solidFill>
               </a:rPr>
-              <a:t>Set up and launch the ads</a:t>
-            </a:r>
-            <a:endParaRPr lang="en-US" sz="1200" dirty="0"/>
+              <a:t>Start the ads</a:t>
+            </a:r>
+            <a:endParaRPr lang="en-US" sz="1300" dirty="0"/>
           </a:p>
         </p:txBody>
       </p:sp>
@@ -10940,14 +10934,14 @@
               <a:buNone/>
             </a:pPr>
             <a:r>
-              <a:rPr lang="en-US" sz="1200" dirty="0">
+              <a:rPr lang="en-US" sz="1300" dirty="0">
                 <a:solidFill>
                   <a:schemeClr val="tx1"/>
                 </a:solidFill>
               </a:rPr>
-              <a:t>Publish content and reply</a:t>
-            </a:r>
-            <a:endParaRPr lang="en-US" sz="1200" dirty="0"/>
+              <a:t>Post and reply</a:t>
+            </a:r>
+            <a:endParaRPr lang="en-US" sz="1300" dirty="0"/>
           </a:p>
         </p:txBody>
       </p:sp>
@@ -11037,14 +11031,14 @@
               <a:buNone/>
             </a:pPr>
             <a:r>
-              <a:rPr lang="en-US" sz="1200" dirty="0">
+              <a:rPr lang="en-US" sz="1300" dirty="0">
                 <a:solidFill>
                   <a:schemeClr val="tx1"/>
                 </a:solidFill>
               </a:rPr>
-              <a:t>Launch the special offers</a:t>
-            </a:r>
-            <a:endParaRPr lang="en-US" sz="1200" dirty="0"/>
+              <a:t>Start the offers</a:t>
+            </a:r>
+            <a:endParaRPr lang="en-US" sz="1300" dirty="0"/>
           </a:p>
         </p:txBody>
       </p:sp>
@@ -11216,14 +11210,14 @@
               <a:buNone/>
             </a:pPr>
             <a:r>
-              <a:rPr lang="en-US" sz="1200" dirty="0">
+              <a:rPr lang="en-US" sz="1300" dirty="0">
                 <a:solidFill>
                   <a:schemeClr val="tx1"/>
                 </a:solidFill>
               </a:rPr>
-              <a:t>Track KPIs, weekly report</a:t>
-            </a:r>
-            <a:endParaRPr lang="en-US" sz="1200" dirty="0"/>
+              <a:t>Weekly report</a:t>
+            </a:r>
+            <a:endParaRPr lang="en-US" sz="1300" dirty="0"/>
           </a:p>
         </p:txBody>
       </p:sp>
@@ -11313,14 +11307,14 @@
               <a:buNone/>
             </a:pPr>
             <a:r>
-              <a:rPr lang="en-US" sz="1200" dirty="0">
+              <a:rPr lang="en-US" sz="1300" dirty="0">
                 <a:solidFill>
                   <a:schemeClr val="tx1"/>
                 </a:solidFill>
               </a:rPr>
-              <a:t>Month-one review and next plan</a:t>
-            </a:r>
-            <a:endParaRPr lang="en-US" sz="1200" dirty="0"/>
+              <a:t>Final review</a:t>
+            </a:r>
+            <a:endParaRPr lang="en-US" sz="1300" dirty="0"/>
           </a:p>
         </p:txBody>
       </p:sp>
@@ -11467,7 +11461,7 @@
                 <a:ea typeface="Cambria" pitchFamily="34" charset="-122"/>
                 <a:cs typeface="Cambria" pitchFamily="34" charset="-120"/>
               </a:rPr>
-              <a:t>Four Weeks, Clear Deadlines</a:t>
+              <a:t>4 Weeks, Clear Deadlines</a:t>
             </a:r>
             <a:endParaRPr lang="en-US" sz="3200" dirty="0"/>
           </a:p>
@@ -11561,8 +11555,8 @@
         </p:nvSpPr>
         <p:spPr>
           <a:xfrm>
-            <a:off x="594360" y="1965960"/>
-            <a:ext cx="1691640" cy="1600200"/>
+            <a:off x="594360" y="2011680"/>
+            <a:ext cx="1691640" cy="1463040"/>
           </a:xfrm>
           <a:prstGeom prst="rect">
             <a:avLst/>
@@ -11576,74 +11570,56 @@
           <a:p>
             <a:pPr marL="342900" indent="-342900">
               <a:spcAft>
-                <a:spcPts val="500"/>
+                <a:spcPts val="600"/>
               </a:spcAft>
               <a:buSzPct val="100000"/>
               <a:buChar char="•"/>
             </a:pPr>
             <a:r>
-              <a:rPr lang="en-US" sz="1300" dirty="0">
+              <a:rPr lang="en-US" sz="1400" dirty="0">
                 <a:solidFill>
                   <a:schemeClr val="tx1"/>
                 </a:solidFill>
               </a:rPr>
-              <a:t>Market research</a:t>
-            </a:r>
-            <a:endParaRPr lang="en-US" sz="1300" dirty="0"/>
+              <a:t>Study the market</a:t>
+            </a:r>
+            <a:endParaRPr lang="en-US" sz="1400" dirty="0"/>
           </a:p>
           <a:p>
             <a:pPr marL="342900" indent="-342900">
               <a:spcAft>
-                <a:spcPts val="500"/>
+                <a:spcPts val="600"/>
               </a:spcAft>
               <a:buSzPct val="100000"/>
               <a:buChar char="•"/>
             </a:pPr>
             <a:r>
-              <a:rPr lang="en-US" sz="1300" dirty="0">
+              <a:rPr lang="en-US" sz="1400" dirty="0">
                 <a:solidFill>
                   <a:schemeClr val="tx1"/>
                 </a:solidFill>
               </a:rPr>
-              <a:t>Target audience</a:t>
-            </a:r>
-            <a:endParaRPr lang="en-US" sz="1300" dirty="0"/>
+              <a:t>Know our customers</a:t>
+            </a:r>
+            <a:endParaRPr lang="en-US" sz="1400" dirty="0"/>
           </a:p>
           <a:p>
             <a:pPr marL="342900" indent="-342900">
               <a:spcAft>
-                <a:spcPts val="500"/>
+                <a:spcPts val="600"/>
               </a:spcAft>
               <a:buSzPct val="100000"/>
               <a:buChar char="•"/>
             </a:pPr>
             <a:r>
-              <a:rPr lang="en-US" sz="1300" dirty="0">
+              <a:rPr lang="en-US" sz="1400" dirty="0">
                 <a:solidFill>
                   <a:schemeClr val="tx1"/>
                 </a:solidFill>
               </a:rPr>
-              <a:t>Free page audit</a:t>
-            </a:r>
-            <a:endParaRPr lang="en-US" sz="1300" dirty="0"/>
-          </a:p>
-          <a:p>
-            <a:pPr marL="342900" indent="-342900">
-              <a:spcAft>
-                <a:spcPts val="500"/>
-              </a:spcAft>
-              <a:buSzPct val="100000"/>
-              <a:buChar char="•"/>
-            </a:pPr>
-            <a:r>
-              <a:rPr lang="en-US" sz="1300" dirty="0">
-                <a:solidFill>
-                  <a:schemeClr val="tx1"/>
-                </a:solidFill>
-              </a:rPr>
-              <a:t>Start content plan</a:t>
-            </a:r>
-            <a:endParaRPr lang="en-US" sz="1300" dirty="0"/>
+              <a:t>Check the pages</a:t>
+            </a:r>
+            <a:endParaRPr lang="en-US" sz="1400" dirty="0"/>
           </a:p>
         </p:txBody>
       </p:sp>
@@ -11708,7 +11684,7 @@
               <a:buNone/>
             </a:pPr>
             <a:r>
-              <a:rPr lang="en-US" sz="1300" b="1" dirty="0">
+              <a:rPr lang="en-US" sz="1400" b="1" dirty="0">
                 <a:solidFill>
                   <a:schemeClr val="bg1"/>
                 </a:solidFill>
@@ -11807,8 +11783,8 @@
         </p:nvSpPr>
         <p:spPr>
           <a:xfrm>
-            <a:off x="2697480" y="1965960"/>
-            <a:ext cx="1691640" cy="1600200"/>
+            <a:off x="2697480" y="2011680"/>
+            <a:ext cx="1691640" cy="1463040"/>
           </a:xfrm>
           <a:prstGeom prst="rect">
             <a:avLst/>
@@ -11822,74 +11798,56 @@
           <a:p>
             <a:pPr marL="342900" indent="-342900">
               <a:spcAft>
-                <a:spcPts val="500"/>
+                <a:spcPts val="600"/>
               </a:spcAft>
               <a:buSzPct val="100000"/>
               <a:buChar char="•"/>
             </a:pPr>
             <a:r>
-              <a:rPr lang="en-US" sz="1300" dirty="0">
+              <a:rPr lang="en-US" sz="1400" dirty="0">
                 <a:solidFill>
                   <a:schemeClr val="tx1"/>
                 </a:solidFill>
               </a:rPr>
-              <a:t>Finish content plan</a:t>
-            </a:r>
-            <a:endParaRPr lang="en-US" sz="1300" dirty="0"/>
+              <a:t>Content plan</a:t>
+            </a:r>
+            <a:endParaRPr lang="en-US" sz="1400" dirty="0"/>
           </a:p>
           <a:p>
             <a:pPr marL="342900" indent="-342900">
               <a:spcAft>
-                <a:spcPts val="500"/>
+                <a:spcPts val="600"/>
               </a:spcAft>
               <a:buSzPct val="100000"/>
               <a:buChar char="•"/>
             </a:pPr>
             <a:r>
-              <a:rPr lang="en-US" sz="1300" dirty="0">
+              <a:rPr lang="en-US" sz="1400" dirty="0">
                 <a:solidFill>
                   <a:schemeClr val="tx1"/>
                 </a:solidFill>
               </a:rPr>
-              <a:t>Photo and video shoot</a:t>
-            </a:r>
-            <a:endParaRPr lang="en-US" sz="1300" dirty="0"/>
+              <a:t>Photos and videos</a:t>
+            </a:r>
+            <a:endParaRPr lang="en-US" sz="1400" dirty="0"/>
           </a:p>
           <a:p>
             <a:pPr marL="342900" indent="-342900">
               <a:spcAft>
-                <a:spcPts val="500"/>
+                <a:spcPts val="600"/>
               </a:spcAft>
               <a:buSzPct val="100000"/>
               <a:buChar char="•"/>
             </a:pPr>
             <a:r>
-              <a:rPr lang="en-US" sz="1300" dirty="0">
+              <a:rPr lang="en-US" sz="1400" dirty="0">
                 <a:solidFill>
                   <a:schemeClr val="tx1"/>
                 </a:solidFill>
               </a:rPr>
-              <a:t>Design content</a:t>
-            </a:r>
-            <a:endParaRPr lang="en-US" sz="1300" dirty="0"/>
-          </a:p>
-          <a:p>
-            <a:pPr marL="342900" indent="-342900">
-              <a:spcAft>
-                <a:spcPts val="500"/>
-              </a:spcAft>
-              <a:buSzPct val="100000"/>
-              <a:buChar char="•"/>
-            </a:pPr>
-            <a:r>
-              <a:rPr lang="en-US" sz="1300" dirty="0">
-                <a:solidFill>
-                  <a:schemeClr val="tx1"/>
-                </a:solidFill>
-              </a:rPr>
-              <a:t>Set up the ads</a:t>
-            </a:r>
-            <a:endParaRPr lang="en-US" sz="1300" dirty="0"/>
+              <a:t>Prepare the ads</a:t>
+            </a:r>
+            <a:endParaRPr lang="en-US" sz="1400" dirty="0"/>
           </a:p>
         </p:txBody>
       </p:sp>
@@ -11954,12 +11912,12 @@
               <a:buNone/>
             </a:pPr>
             <a:r>
-              <a:rPr lang="en-US" sz="1300" b="1" dirty="0">
+              <a:rPr lang="en-US" sz="1400" b="1" dirty="0">
                 <a:solidFill>
                   <a:schemeClr val="bg1"/>
                 </a:solidFill>
               </a:rPr>
-              <a:t>Content and ads ready</a:t>
+              <a:t>Content ready</a:t>
             </a:r>
             <a:endParaRPr lang="en-US" sz="1000" dirty="0"/>
           </a:p>
@@ -12053,8 +12011,8 @@
         </p:nvSpPr>
         <p:spPr>
           <a:xfrm>
-            <a:off x="4800600" y="1965960"/>
-            <a:ext cx="1691640" cy="1600200"/>
+            <a:off x="4800600" y="2011680"/>
+            <a:ext cx="1691640" cy="1463040"/>
           </a:xfrm>
           <a:prstGeom prst="rect">
             <a:avLst/>
@@ -12068,74 +12026,56 @@
           <a:p>
             <a:pPr marL="342900" indent="-342900">
               <a:spcAft>
-                <a:spcPts val="500"/>
+                <a:spcPts val="600"/>
               </a:spcAft>
               <a:buSzPct val="100000"/>
               <a:buChar char="•"/>
             </a:pPr>
             <a:r>
-              <a:rPr lang="en-US" sz="1300" dirty="0">
+              <a:rPr lang="en-US" sz="1400" dirty="0">
                 <a:solidFill>
                   <a:schemeClr val="tx1"/>
                 </a:solidFill>
               </a:rPr>
-              <a:t>Launch the ads</a:t>
-            </a:r>
-            <a:endParaRPr lang="en-US" sz="1300" dirty="0"/>
+              <a:t>Start the ads</a:t>
+            </a:r>
+            <a:endParaRPr lang="en-US" sz="1400" dirty="0"/>
           </a:p>
           <a:p>
             <a:pPr marL="342900" indent="-342900">
               <a:spcAft>
-                <a:spcPts val="500"/>
+                <a:spcPts val="600"/>
               </a:spcAft>
               <a:buSzPct val="100000"/>
               <a:buChar char="•"/>
             </a:pPr>
             <a:r>
-              <a:rPr lang="en-US" sz="1300" dirty="0">
+              <a:rPr lang="en-US" sz="1400" dirty="0">
                 <a:solidFill>
                   <a:schemeClr val="tx1"/>
                 </a:solidFill>
               </a:rPr>
-              <a:t>Publish and reply</a:t>
-            </a:r>
-            <a:endParaRPr lang="en-US" sz="1300" dirty="0"/>
+              <a:t>Post and reply</a:t>
+            </a:r>
+            <a:endParaRPr lang="en-US" sz="1400" dirty="0"/>
           </a:p>
           <a:p>
             <a:pPr marL="342900" indent="-342900">
               <a:spcAft>
-                <a:spcPts val="500"/>
+                <a:spcPts val="600"/>
               </a:spcAft>
               <a:buSzPct val="100000"/>
               <a:buChar char="•"/>
             </a:pPr>
             <a:r>
-              <a:rPr lang="en-US" sz="1300" dirty="0">
+              <a:rPr lang="en-US" sz="1400" dirty="0">
                 <a:solidFill>
                   <a:schemeClr val="tx1"/>
                 </a:solidFill>
               </a:rPr>
-              <a:t>Launch offers</a:t>
-            </a:r>
-            <a:endParaRPr lang="en-US" sz="1300" dirty="0"/>
-          </a:p>
-          <a:p>
-            <a:pPr marL="342900" indent="-342900">
-              <a:spcAft>
-                <a:spcPts val="500"/>
-              </a:spcAft>
-              <a:buSzPct val="100000"/>
-              <a:buChar char="•"/>
-            </a:pPr>
-            <a:r>
-              <a:rPr lang="en-US" sz="1300" dirty="0">
-                <a:solidFill>
-                  <a:schemeClr val="tx1"/>
-                </a:solidFill>
-              </a:rPr>
-              <a:t>Keep creating</a:t>
-            </a:r>
-            <a:endParaRPr lang="en-US" sz="1300" dirty="0"/>
+              <a:t>Start the offers</a:t>
+            </a:r>
+            <a:endParaRPr lang="en-US" sz="1400" dirty="0"/>
           </a:p>
         </p:txBody>
       </p:sp>
@@ -12200,7 +12140,7 @@
               <a:buNone/>
             </a:pPr>
             <a:r>
-              <a:rPr lang="en-US" sz="1300" b="1" dirty="0">
+              <a:rPr lang="en-US" sz="1400" b="1" dirty="0">
                 <a:solidFill>
                   <a:schemeClr val="bg1"/>
                 </a:solidFill>
@@ -12299,8 +12239,8 @@
         </p:nvSpPr>
         <p:spPr>
           <a:xfrm>
-            <a:off x="6903720" y="1965960"/>
-            <a:ext cx="1691640" cy="1600200"/>
+            <a:off x="6903720" y="2011680"/>
+            <a:ext cx="1691640" cy="1463040"/>
           </a:xfrm>
           <a:prstGeom prst="rect">
             <a:avLst/>
@@ -12314,74 +12254,56 @@
           <a:p>
             <a:pPr marL="342900" indent="-342900">
               <a:spcAft>
-                <a:spcPts val="500"/>
+                <a:spcPts val="600"/>
               </a:spcAft>
               <a:buSzPct val="100000"/>
               <a:buChar char="•"/>
             </a:pPr>
             <a:r>
-              <a:rPr lang="en-US" sz="1300" dirty="0">
+              <a:rPr lang="en-US" sz="1400" dirty="0">
                 <a:solidFill>
                   <a:schemeClr val="tx1"/>
                 </a:solidFill>
               </a:rPr>
-              <a:t>Keep publishing</a:t>
-            </a:r>
-            <a:endParaRPr lang="en-US" sz="1300" dirty="0"/>
+              <a:t>Keep posting</a:t>
+            </a:r>
+            <a:endParaRPr lang="en-US" sz="1400" dirty="0"/>
           </a:p>
           <a:p>
             <a:pPr marL="342900" indent="-342900">
               <a:spcAft>
-                <a:spcPts val="500"/>
+                <a:spcPts val="600"/>
               </a:spcAft>
               <a:buSzPct val="100000"/>
               <a:buChar char="•"/>
             </a:pPr>
             <a:r>
-              <a:rPr lang="en-US" sz="1300" dirty="0">
+              <a:rPr lang="en-US" sz="1400" dirty="0">
                 <a:solidFill>
                   <a:schemeClr val="tx1"/>
                 </a:solidFill>
               </a:rPr>
-              <a:t>Adjust the ads</a:t>
-            </a:r>
-            <a:endParaRPr lang="en-US" sz="1300" dirty="0"/>
+              <a:t>Improve the ads</a:t>
+            </a:r>
+            <a:endParaRPr lang="en-US" sz="1400" dirty="0"/>
           </a:p>
           <a:p>
             <a:pPr marL="342900" indent="-342900">
               <a:spcAft>
-                <a:spcPts val="500"/>
+                <a:spcPts val="600"/>
               </a:spcAft>
               <a:buSzPct val="100000"/>
               <a:buChar char="•"/>
             </a:pPr>
             <a:r>
-              <a:rPr lang="en-US" sz="1300" dirty="0">
+              <a:rPr lang="en-US" sz="1400" dirty="0">
                 <a:solidFill>
                   <a:schemeClr val="tx1"/>
                 </a:solidFill>
               </a:rPr>
-              <a:t>Final report</a:t>
-            </a:r>
-            <a:endParaRPr lang="en-US" sz="1300" dirty="0"/>
-          </a:p>
-          <a:p>
-            <a:pPr marL="342900" indent="-342900">
-              <a:spcAft>
-                <a:spcPts val="500"/>
-              </a:spcAft>
-              <a:buSzPct val="100000"/>
-              <a:buChar char="•"/>
-            </a:pPr>
-            <a:r>
-              <a:rPr lang="en-US" sz="1300" dirty="0">
-                <a:solidFill>
-                  <a:schemeClr val="tx1"/>
-                </a:solidFill>
-              </a:rPr>
-              <a:t>Month-one review</a:t>
-            </a:r>
-            <a:endParaRPr lang="en-US" sz="1300" dirty="0"/>
+              <a:t>Final review</a:t>
+            </a:r>
+            <a:endParaRPr lang="en-US" sz="1400" dirty="0"/>
           </a:p>
         </p:txBody>
       </p:sp>
@@ -12446,12 +12368,12 @@
               <a:buNone/>
             </a:pPr>
             <a:r>
-              <a:rPr lang="en-US" sz="1300" b="1" dirty="0">
+              <a:rPr lang="en-US" sz="1400" b="1" dirty="0">
                 <a:solidFill>
                   <a:schemeClr val="bg1"/>
                 </a:solidFill>
               </a:rPr>
-              <a:t>Review delivered</a:t>
+              <a:t>Review done</a:t>
             </a:r>
             <a:endParaRPr lang="en-US" sz="1000" dirty="0"/>
           </a:p>
@@ -12600,7 +12522,7 @@
                 <a:ea typeface="Cambria" pitchFamily="34" charset="-122"/>
                 <a:cs typeface="Cambria" pitchFamily="34" charset="-120"/>
               </a:rPr>
-              <a:t>One Clear Owner for Every Task</a:t>
+              <a:t>Who Does What</a:t>
             </a:r>
             <a:endParaRPr lang="en-US" sz="3200" dirty="0"/>
           </a:p>
@@ -12681,7 +12603,7 @@
         <p:spPr>
           <a:xfrm>
             <a:off x="640080" y="2176272"/>
-            <a:ext cx="1645920" cy="640080"/>
+            <a:ext cx="1645920" cy="594360"/>
           </a:xfrm>
           <a:prstGeom prst="rect">
             <a:avLst/>
@@ -12711,7 +12633,7 @@
               <a:buNone/>
             </a:pPr>
             <a:r>
-              <a:rPr lang="en-US" sz="1200" b="1" dirty="0">
+              <a:rPr lang="en-US" sz="1300" b="1" dirty="0">
                 <a:solidFill>
                   <a:schemeClr val="accent1"/>
                 </a:solidFill>
@@ -12724,7 +12646,7 @@
       </p:sp>
       <p:sp>
         <p:nvSpPr>
-          <p:cNvPr id="8" name="Owns label 1"/>
+          <p:cNvPr id="8" name="Tasks label 1"/>
           <p:cNvSpPr txBox="1"/>
           <p:nvPr/>
         </p:nvSpPr>
@@ -12752,7 +12674,7 @@
                   <a:schemeClr val="accent5"/>
                 </a:solidFill>
               </a:rPr>
-              <a:t>OWNS</a:t>
+              <a:t>TASKS</a:t>
             </a:r>
             <a:endParaRPr lang="en-US" sz="1000" dirty="0"/>
           </a:p>
@@ -12766,8 +12688,8 @@
         </p:nvSpPr>
         <p:spPr>
           <a:xfrm>
-            <a:off x="640080" y="3108960"/>
-            <a:ext cx="1645920" cy="1371600"/>
+            <a:off x="640080" y="3127248"/>
+            <a:ext cx="1645920" cy="1325880"/>
           </a:xfrm>
           <a:prstGeom prst="rect">
             <a:avLst/>
@@ -12781,74 +12703,56 @@
           <a:p>
             <a:pPr marL="342900" indent="-342900">
               <a:spcAft>
-                <a:spcPts val="300"/>
+                <a:spcPts val="400"/>
               </a:spcAft>
               <a:buSzPct val="100000"/>
               <a:buChar char="•"/>
             </a:pPr>
             <a:r>
-              <a:rPr lang="en-US" sz="1200" dirty="0">
+              <a:rPr lang="en-US" sz="1400" dirty="0">
                 <a:solidFill>
                   <a:schemeClr val="tx1"/>
                 </a:solidFill>
               </a:rPr>
-              <a:t>Market research</a:t>
-            </a:r>
-            <a:endParaRPr lang="en-US" sz="1200" dirty="0"/>
+              <a:t>Market study</a:t>
+            </a:r>
+            <a:endParaRPr lang="en-US" sz="1400" dirty="0"/>
           </a:p>
           <a:p>
             <a:pPr marL="342900" indent="-342900">
               <a:spcAft>
-                <a:spcPts val="300"/>
+                <a:spcPts val="400"/>
               </a:spcAft>
               <a:buSzPct val="100000"/>
               <a:buChar char="•"/>
             </a:pPr>
             <a:r>
-              <a:rPr lang="en-US" sz="1200" dirty="0">
+              <a:rPr lang="en-US" sz="1400" dirty="0">
                 <a:solidFill>
                   <a:schemeClr val="tx1"/>
                 </a:solidFill>
               </a:rPr>
-              <a:t>Target audience</a:t>
-            </a:r>
-            <a:endParaRPr lang="en-US" sz="1200" dirty="0"/>
+              <a:t>Customer research</a:t>
+            </a:r>
+            <a:endParaRPr lang="en-US" sz="1400" dirty="0"/>
           </a:p>
           <a:p>
             <a:pPr marL="342900" indent="-342900">
               <a:spcAft>
-                <a:spcPts val="300"/>
+                <a:spcPts val="400"/>
               </a:spcAft>
               <a:buSzPct val="100000"/>
               <a:buChar char="•"/>
             </a:pPr>
             <a:r>
-              <a:rPr lang="en-US" sz="1200" dirty="0">
+              <a:rPr lang="en-US" sz="1400" dirty="0">
                 <a:solidFill>
                   <a:schemeClr val="tx1"/>
                 </a:solidFill>
               </a:rPr>
-              <a:t>Month-one review</a:t>
-            </a:r>
-            <a:endParaRPr lang="en-US" sz="1200" dirty="0"/>
-          </a:p>
-          <a:p>
-            <a:pPr marL="342900" indent="-342900">
-              <a:spcAft>
-                <a:spcPts val="300"/>
-              </a:spcAft>
-              <a:buSzPct val="100000"/>
-              <a:buChar char="•"/>
-            </a:pPr>
-            <a:r>
-              <a:rPr lang="en-US" sz="1200" dirty="0">
-                <a:solidFill>
-                  <a:schemeClr val="tx1"/>
-                </a:solidFill>
-              </a:rPr>
-              <a:t>Main contact for the owner</a:t>
-            </a:r>
-            <a:endParaRPr lang="en-US" sz="1200" dirty="0"/>
+              <a:t>Final review</a:t>
+            </a:r>
+            <a:endParaRPr lang="en-US" sz="1400" dirty="0"/>
           </a:p>
         </p:txBody>
       </p:sp>
@@ -12927,7 +12831,7 @@
         <p:spPr>
           <a:xfrm>
             <a:off x="2743200" y="2176272"/>
-            <a:ext cx="1645920" cy="640080"/>
+            <a:ext cx="1645920" cy="594360"/>
           </a:xfrm>
           <a:prstGeom prst="rect">
             <a:avLst/>
@@ -12957,12 +12861,12 @@
               <a:buNone/>
             </a:pPr>
             <a:r>
-              <a:rPr lang="en-US" sz="1200" b="1" dirty="0">
+              <a:rPr lang="en-US" sz="1300" b="1" dirty="0">
                 <a:solidFill>
                   <a:schemeClr val="accent1"/>
                 </a:solidFill>
               </a:rPr>
-              <a:t>Social media and content</a:t>
+              <a:t>Social media</a:t>
             </a:r>
             <a:endParaRPr lang="en-US" sz="1500" dirty="0"/>
           </a:p>
@@ -12970,7 +12874,7 @@
       </p:sp>
       <p:sp>
         <p:nvSpPr>
-          <p:cNvPr id="14" name="Owns label 2"/>
+          <p:cNvPr id="14" name="Tasks label 2"/>
           <p:cNvSpPr txBox="1"/>
           <p:nvPr/>
         </p:nvSpPr>
@@ -12998,7 +12902,7 @@
                   <a:schemeClr val="accent5"/>
                 </a:solidFill>
               </a:rPr>
-              <a:t>OWNS</a:t>
+              <a:t>TASKS</a:t>
             </a:r>
             <a:endParaRPr lang="en-US" sz="1000" dirty="0"/>
           </a:p>
@@ -13012,8 +12916,8 @@
         </p:nvSpPr>
         <p:spPr>
           <a:xfrm>
-            <a:off x="2743200" y="3108960"/>
-            <a:ext cx="1645920" cy="1371600"/>
+            <a:off x="2743200" y="3127248"/>
+            <a:ext cx="1645920" cy="1325880"/>
           </a:xfrm>
           <a:prstGeom prst="rect">
             <a:avLst/>
@@ -13027,56 +12931,56 @@
           <a:p>
             <a:pPr marL="342900" indent="-342900">
               <a:spcAft>
-                <a:spcPts val="300"/>
+                <a:spcPts val="400"/>
               </a:spcAft>
               <a:buSzPct val="100000"/>
               <a:buChar char="•"/>
             </a:pPr>
             <a:r>
-              <a:rPr lang="en-US" sz="1200" dirty="0">
+              <a:rPr lang="en-US" sz="1400" dirty="0">
                 <a:solidFill>
                   <a:schemeClr val="tx1"/>
                 </a:solidFill>
               </a:rPr>
               <a:t>Content plan</a:t>
             </a:r>
-            <a:endParaRPr lang="en-US" sz="1200" dirty="0"/>
+            <a:endParaRPr lang="en-US" sz="1400" dirty="0"/>
           </a:p>
           <a:p>
             <a:pPr marL="342900" indent="-342900">
               <a:spcAft>
-                <a:spcPts val="300"/>
+                <a:spcPts val="400"/>
               </a:spcAft>
               <a:buSzPct val="100000"/>
               <a:buChar char="•"/>
             </a:pPr>
             <a:r>
-              <a:rPr lang="en-US" sz="1200" dirty="0">
+              <a:rPr lang="en-US" sz="1400" dirty="0">
                 <a:solidFill>
                   <a:schemeClr val="tx1"/>
                 </a:solidFill>
               </a:rPr>
-              <a:t>Publishing and replies</a:t>
-            </a:r>
-            <a:endParaRPr lang="en-US" sz="1200" dirty="0"/>
+              <a:t>Posting and replies</a:t>
+            </a:r>
+            <a:endParaRPr lang="en-US" sz="1400" dirty="0"/>
           </a:p>
           <a:p>
             <a:pPr marL="342900" indent="-342900">
               <a:spcAft>
-                <a:spcPts val="300"/>
+                <a:spcPts val="400"/>
               </a:spcAft>
               <a:buSzPct val="100000"/>
               <a:buChar char="•"/>
             </a:pPr>
             <a:r>
-              <a:rPr lang="en-US" sz="1200" dirty="0">
+              <a:rPr lang="en-US" sz="1400" dirty="0">
                 <a:solidFill>
                   <a:schemeClr val="tx1"/>
                 </a:solidFill>
               </a:rPr>
-              <a:t>Special offers</a:t>
-            </a:r>
-            <a:endParaRPr lang="en-US" sz="1200" dirty="0"/>
+              <a:t>Offers</a:t>
+            </a:r>
+            <a:endParaRPr lang="en-US" sz="1400" dirty="0"/>
           </a:p>
         </p:txBody>
       </p:sp>
@@ -13155,7 +13059,7 @@
         <p:spPr>
           <a:xfrm>
             <a:off x="4846320" y="2176272"/>
-            <a:ext cx="1645920" cy="640080"/>
+            <a:ext cx="1645920" cy="594360"/>
           </a:xfrm>
           <a:prstGeom prst="rect">
             <a:avLst/>
@@ -13185,12 +13089,12 @@
               <a:buNone/>
             </a:pPr>
             <a:r>
-              <a:rPr lang="en-US" sz="1200" b="1" dirty="0">
+              <a:rPr lang="en-US" sz="1300" b="1" dirty="0">
                 <a:solidFill>
                   <a:schemeClr val="accent4"/>
                 </a:solidFill>
               </a:rPr>
-              <a:t>Ads and analytics</a:t>
+              <a:t>Ads and reports</a:t>
             </a:r>
             <a:endParaRPr lang="en-US" sz="1500" dirty="0"/>
           </a:p>
@@ -13198,7 +13102,7 @@
       </p:sp>
       <p:sp>
         <p:nvSpPr>
-          <p:cNvPr id="20" name="Owns label 3"/>
+          <p:cNvPr id="20" name="Tasks label 3"/>
           <p:cNvSpPr txBox="1"/>
           <p:nvPr/>
         </p:nvSpPr>
@@ -13226,7 +13130,7 @@
                   <a:schemeClr val="accent5"/>
                 </a:solidFill>
               </a:rPr>
-              <a:t>OWNS</a:t>
+              <a:t>TASKS</a:t>
             </a:r>
             <a:endParaRPr lang="en-US" sz="1000" dirty="0"/>
           </a:p>
@@ -13240,8 +13144,8 @@
         </p:nvSpPr>
         <p:spPr>
           <a:xfrm>
-            <a:off x="4846320" y="3108960"/>
-            <a:ext cx="1645920" cy="1371600"/>
+            <a:off x="4846320" y="3127248"/>
+            <a:ext cx="1645920" cy="1325880"/>
           </a:xfrm>
           <a:prstGeom prst="rect">
             <a:avLst/>
@@ -13255,56 +13159,56 @@
           <a:p>
             <a:pPr marL="342900" indent="-342900">
               <a:spcAft>
-                <a:spcPts val="300"/>
+                <a:spcPts val="400"/>
               </a:spcAft>
               <a:buSzPct val="100000"/>
               <a:buChar char="•"/>
             </a:pPr>
             <a:r>
-              <a:rPr lang="en-US" sz="1200" dirty="0">
+              <a:rPr lang="en-US" sz="1400" dirty="0">
                 <a:solidFill>
                   <a:schemeClr val="tx1"/>
                 </a:solidFill>
               </a:rPr>
-              <a:t>Free page audit</a:t>
-            </a:r>
-            <a:endParaRPr lang="en-US" sz="1200" dirty="0"/>
+              <a:t>Page check</a:t>
+            </a:r>
+            <a:endParaRPr lang="en-US" sz="1400" dirty="0"/>
           </a:p>
           <a:p>
             <a:pPr marL="342900" indent="-342900">
               <a:spcAft>
-                <a:spcPts val="300"/>
+                <a:spcPts val="400"/>
               </a:spcAft>
               <a:buSzPct val="100000"/>
               <a:buChar char="•"/>
             </a:pPr>
             <a:r>
-              <a:rPr lang="en-US" sz="1200" dirty="0">
+              <a:rPr lang="en-US" sz="1400" dirty="0">
                 <a:solidFill>
                   <a:schemeClr val="tx1"/>
                 </a:solidFill>
               </a:rPr>
-              <a:t>Facebook and Instagram ads</a:t>
-            </a:r>
-            <a:endParaRPr lang="en-US" sz="1200" dirty="0"/>
+              <a:t>Ads</a:t>
+            </a:r>
+            <a:endParaRPr lang="en-US" sz="1400" dirty="0"/>
           </a:p>
           <a:p>
             <a:pPr marL="342900" indent="-342900">
               <a:spcAft>
-                <a:spcPts val="300"/>
+                <a:spcPts val="400"/>
               </a:spcAft>
               <a:buSzPct val="100000"/>
               <a:buChar char="•"/>
             </a:pPr>
             <a:r>
-              <a:rPr lang="en-US" sz="1200" dirty="0">
+              <a:rPr lang="en-US" sz="1400" dirty="0">
                 <a:solidFill>
                   <a:schemeClr val="tx1"/>
                 </a:solidFill>
               </a:rPr>
-              <a:t>KPIs and weekly report</a:t>
-            </a:r>
-            <a:endParaRPr lang="en-US" sz="1200" dirty="0"/>
+              <a:t>Weekly report</a:t>
+            </a:r>
+            <a:endParaRPr lang="en-US" sz="1400" dirty="0"/>
           </a:p>
         </p:txBody>
       </p:sp>
@@ -13383,7 +13287,7 @@
         <p:spPr>
           <a:xfrm>
             <a:off x="6949440" y="2176272"/>
-            <a:ext cx="1645920" cy="640080"/>
+            <a:ext cx="1645920" cy="594360"/>
           </a:xfrm>
           <a:prstGeom prst="rect">
             <a:avLst/>
@@ -13413,12 +13317,12 @@
               <a:buNone/>
             </a:pPr>
             <a:r>
-              <a:rPr lang="en-US" sz="1200" b="1" dirty="0">
+              <a:rPr lang="en-US" sz="1300" b="1" dirty="0">
                 <a:solidFill>
                   <a:schemeClr val="accent3"/>
                 </a:solidFill>
               </a:rPr>
-              <a:t>Design and photography</a:t>
+              <a:t>Design and photos</a:t>
             </a:r>
             <a:endParaRPr lang="en-US" sz="1500" dirty="0"/>
           </a:p>
@@ -13426,7 +13330,7 @@
       </p:sp>
       <p:sp>
         <p:nvSpPr>
-          <p:cNvPr id="26" name="Owns label 4"/>
+          <p:cNvPr id="26" name="Tasks label 4"/>
           <p:cNvSpPr txBox="1"/>
           <p:nvPr/>
         </p:nvSpPr>
@@ -13454,7 +13358,7 @@
                   <a:schemeClr val="accent5"/>
                 </a:solidFill>
               </a:rPr>
-              <a:t>OWNS</a:t>
+              <a:t>TASKS</a:t>
             </a:r>
             <a:endParaRPr lang="en-US" sz="1000" dirty="0"/>
           </a:p>
@@ -13468,8 +13372,8 @@
         </p:nvSpPr>
         <p:spPr>
           <a:xfrm>
-            <a:off x="6949440" y="3108960"/>
-            <a:ext cx="1645920" cy="1371600"/>
+            <a:off x="6949440" y="3127248"/>
+            <a:ext cx="1645920" cy="1325880"/>
           </a:xfrm>
           <a:prstGeom prst="rect">
             <a:avLst/>
@@ -13483,38 +13387,38 @@
           <a:p>
             <a:pPr marL="342900" indent="-342900">
               <a:spcAft>
-                <a:spcPts val="300"/>
+                <a:spcPts val="400"/>
               </a:spcAft>
               <a:buSzPct val="100000"/>
               <a:buChar char="•"/>
             </a:pPr>
             <a:r>
-              <a:rPr lang="en-US" sz="1200" dirty="0">
+              <a:rPr lang="en-US" sz="1400" dirty="0">
                 <a:solidFill>
                   <a:schemeClr val="tx1"/>
                 </a:solidFill>
               </a:rPr>
-              <a:t>Photo and video shoot</a:t>
-            </a:r>
-            <a:endParaRPr lang="en-US" sz="1200" dirty="0"/>
+              <a:t>Photos and videos</a:t>
+            </a:r>
+            <a:endParaRPr lang="en-US" sz="1400" dirty="0"/>
           </a:p>
           <a:p>
             <a:pPr marL="342900" indent="-342900">
               <a:spcAft>
-                <a:spcPts val="300"/>
+                <a:spcPts val="400"/>
               </a:spcAft>
               <a:buSzPct val="100000"/>
               <a:buChar char="•"/>
             </a:pPr>
             <a:r>
-              <a:rPr lang="en-US" sz="1200" dirty="0">
+              <a:rPr lang="en-US" sz="1400" dirty="0">
                 <a:solidFill>
                   <a:schemeClr val="tx1"/>
                 </a:solidFill>
               </a:rPr>
-              <a:t>Posts, reels and stories design</a:t>
-            </a:r>
-            <a:endParaRPr lang="en-US" sz="1200" dirty="0"/>
+              <a:t>Post design</a:t>
+            </a:r>
+            <a:endParaRPr lang="en-US" sz="1400" dirty="0"/>
           </a:p>
         </p:txBody>
       </p:sp>
@@ -13661,7 +13565,7 @@
                 <a:ea typeface="Cambria" pitchFamily="34" charset="-122"/>
                 <a:cs typeface="Cambria" pitchFamily="34" charset="-120"/>
               </a:rPr>
-              <a:t>What We Need to Succeed</a:t>
+              <a:t>What We Need</a:t>
             </a:r>
             <a:endParaRPr lang="en-US" sz="3200" dirty="0"/>
           </a:p>
@@ -13778,14 +13682,14 @@
               <a:buChar char="•"/>
             </a:pPr>
             <a:r>
-              <a:rPr lang="en-US" sz="1300" dirty="0">
+              <a:rPr lang="en-US" sz="1400" dirty="0">
                 <a:solidFill>
                   <a:schemeClr val="tx1"/>
                 </a:solidFill>
               </a:rPr>
-              <a:t>Social media: 5,000 EGP</a:t>
-            </a:r>
-            <a:endParaRPr lang="en-US" sz="1300" dirty="0"/>
+              <a:t>Social media: 5,000</a:t>
+            </a:r>
+            <a:endParaRPr lang="en-US" sz="1400" dirty="0"/>
           </a:p>
           <a:p>
             <a:pPr marL="342900" indent="-342900">
@@ -13796,14 +13700,14 @@
               <a:buChar char="•"/>
             </a:pPr>
             <a:r>
-              <a:rPr lang="en-US" sz="1300" dirty="0">
+              <a:rPr lang="en-US" sz="1400" dirty="0">
                 <a:solidFill>
                   <a:schemeClr val="tx1"/>
                 </a:solidFill>
               </a:rPr>
-              <a:t>Paid ads: 4,000 EGP</a:t>
-            </a:r>
-            <a:endParaRPr lang="en-US" sz="1300" dirty="0"/>
+              <a:t>Ads: 4,000</a:t>
+            </a:r>
+            <a:endParaRPr lang="en-US" sz="1400" dirty="0"/>
           </a:p>
           <a:p>
             <a:pPr marL="342900" indent="-342900">
@@ -13814,14 +13718,14 @@
               <a:buChar char="•"/>
             </a:pPr>
             <a:r>
-              <a:rPr lang="en-US" sz="1300" dirty="0">
+              <a:rPr lang="en-US" sz="1400" dirty="0">
                 <a:solidFill>
                   <a:schemeClr val="tx1"/>
                 </a:solidFill>
               </a:rPr>
-              <a:t>Content: 3,000 EGP</a:t>
-            </a:r>
-            <a:endParaRPr lang="en-US" sz="1300" dirty="0"/>
+              <a:t>Content: 3,000</a:t>
+            </a:r>
+            <a:endParaRPr lang="en-US" sz="1400" dirty="0"/>
           </a:p>
           <a:p>
             <a:pPr marL="342900" indent="-342900">
@@ -13832,14 +13736,14 @@
               <a:buChar char="•"/>
             </a:pPr>
             <a:r>
-              <a:rPr lang="en-US" sz="1300" dirty="0">
+              <a:rPr lang="en-US" sz="1400" dirty="0">
                 <a:solidFill>
                   <a:schemeClr val="tx1"/>
                 </a:solidFill>
               </a:rPr>
-              <a:t>Reports: 1,000 EGP</a:t>
-            </a:r>
-            <a:endParaRPr lang="en-US" sz="1300" dirty="0"/>
+              <a:t>Reports: 1,000</a:t>
+            </a:r>
+            <a:endParaRPr lang="en-US" sz="1400" dirty="0"/>
           </a:p>
         </p:txBody>
       </p:sp>
@@ -13954,14 +13858,14 @@
               <a:buChar char="•"/>
             </a:pPr>
             <a:r>
-              <a:rPr lang="en-US" sz="1300" dirty="0">
+              <a:rPr lang="en-US" sz="1400" dirty="0">
                 <a:solidFill>
                   <a:schemeClr val="tx1"/>
                 </a:solidFill>
               </a:rPr>
               <a:t>Meta Business Suite</a:t>
             </a:r>
-            <a:endParaRPr lang="en-US" sz="1300" dirty="0"/>
+            <a:endParaRPr lang="en-US" sz="1400" dirty="0"/>
           </a:p>
           <a:p>
             <a:pPr marL="342900" indent="-342900">
@@ -13972,14 +13876,14 @@
               <a:buChar char="•"/>
             </a:pPr>
             <a:r>
-              <a:rPr lang="en-US" sz="1300" dirty="0">
+              <a:rPr lang="en-US" sz="1400" dirty="0">
                 <a:solidFill>
                   <a:schemeClr val="tx1"/>
                 </a:solidFill>
               </a:rPr>
               <a:t>Meta Ads Manager</a:t>
             </a:r>
-            <a:endParaRPr lang="en-US" sz="1300" dirty="0"/>
+            <a:endParaRPr lang="en-US" sz="1400" dirty="0"/>
           </a:p>
           <a:p>
             <a:pPr marL="342900" indent="-342900">
@@ -13990,14 +13894,14 @@
               <a:buChar char="•"/>
             </a:pPr>
             <a:r>
-              <a:rPr lang="en-US" sz="1300" dirty="0">
+              <a:rPr lang="en-US" sz="1400" dirty="0">
                 <a:solidFill>
                   <a:schemeClr val="tx1"/>
                 </a:solidFill>
               </a:rPr>
               <a:t>Canva and CapCut</a:t>
             </a:r>
-            <a:endParaRPr lang="en-US" sz="1300" dirty="0"/>
+            <a:endParaRPr lang="en-US" sz="1400" dirty="0"/>
           </a:p>
           <a:p>
             <a:pPr marL="342900" indent="-342900">
@@ -14008,14 +13912,14 @@
               <a:buChar char="•"/>
             </a:pPr>
             <a:r>
-              <a:rPr lang="en-US" sz="1300" dirty="0">
+              <a:rPr lang="en-US" sz="1400" dirty="0">
                 <a:solidFill>
                   <a:schemeClr val="tx1"/>
                 </a:solidFill>
               </a:rPr>
-              <a:t>Google Sheets reports</a:t>
-            </a:r>
-            <a:endParaRPr lang="en-US" sz="1300" dirty="0"/>
+              <a:t>Google Sheets</a:t>
+            </a:r>
+            <a:endParaRPr lang="en-US" sz="1400" dirty="0"/>
           </a:p>
         </p:txBody>
       </p:sp>
@@ -14043,7 +13947,7 @@
       </p:sp>
       <p:pic>
         <p:nvPicPr>
-          <p:cNvPr id="13" name="From The Daily Cup illustration" descr="From The Daily Cup illustration">    </p:cNvPr>
+          <p:cNvPr id="13" name="From the café illustration" descr="From the café illustration">    </p:cNvPr>
           <p:cNvPicPr>
             <a:picLocks noChangeAspect="1"/>
           </p:cNvPicPr>
@@ -14095,7 +13999,7 @@
                   <a:schemeClr val="tx2"/>
                 </a:solidFill>
               </a:rPr>
-              <a:t>From The Daily Cup</a:t>
+              <a:t>From the café</a:t>
             </a:r>
             <a:endParaRPr lang="en-US" sz="1500" dirty="0"/>
           </a:p>
@@ -14130,14 +14034,14 @@
               <a:buChar char="•"/>
             </a:pPr>
             <a:r>
-              <a:rPr lang="en-US" sz="1300" dirty="0">
+              <a:rPr lang="en-US" sz="1400" dirty="0">
                 <a:solidFill>
                   <a:schemeClr val="tx1"/>
                 </a:solidFill>
               </a:rPr>
-              <a:t>Access to the café's pages</a:t>
-            </a:r>
-            <a:endParaRPr lang="en-US" sz="1300" dirty="0"/>
+              <a:t>Page access</a:t>
+            </a:r>
+            <a:endParaRPr lang="en-US" sz="1400" dirty="0"/>
           </a:p>
           <a:p>
             <a:pPr marL="342900" indent="-342900">
@@ -14148,14 +14052,14 @@
               <a:buChar char="•"/>
             </a:pPr>
             <a:r>
-              <a:rPr lang="en-US" sz="1300" dirty="0">
+              <a:rPr lang="en-US" sz="1400" dirty="0">
                 <a:solidFill>
                   <a:schemeClr val="tx1"/>
                 </a:solidFill>
               </a:rPr>
-              <a:t>Menu, prices and offers</a:t>
-            </a:r>
-            <a:endParaRPr lang="en-US" sz="1300" dirty="0"/>
+              <a:t>Menu and prices</a:t>
+            </a:r>
+            <a:endParaRPr lang="en-US" sz="1400" dirty="0"/>
           </a:p>
           <a:p>
             <a:pPr marL="342900" indent="-342900">
@@ -14166,14 +14070,14 @@
               <a:buChar char="•"/>
             </a:pPr>
             <a:r>
-              <a:rPr lang="en-US" sz="1300" dirty="0">
+              <a:rPr lang="en-US" sz="1400" dirty="0">
                 <a:solidFill>
                   <a:schemeClr val="tx1"/>
                 </a:solidFill>
               </a:rPr>
-              <a:t>Time for the photo shoot</a:t>
-            </a:r>
-            <a:endParaRPr lang="en-US" sz="1300" dirty="0"/>
+              <a:t>Time for photos</a:t>
+            </a:r>
+            <a:endParaRPr lang="en-US" sz="1400" dirty="0"/>
           </a:p>
           <a:p>
             <a:pPr marL="342900" indent="-342900">
@@ -14184,14 +14088,14 @@
               <a:buChar char="•"/>
             </a:pPr>
             <a:r>
-              <a:rPr lang="en-US" sz="1300" dirty="0">
+              <a:rPr lang="en-US" sz="1400" dirty="0">
                 <a:solidFill>
                   <a:schemeClr val="tx1"/>
                 </a:solidFill>
               </a:rPr>
-              <a:t>Weekly sales numbers</a:t>
-            </a:r>
-            <a:endParaRPr lang="en-US" sz="1300" dirty="0"/>
+              <a:t>Weekly sales</a:t>
+            </a:r>
+            <a:endParaRPr lang="en-US" sz="1400" dirty="0"/>
           </a:p>
         </p:txBody>
       </p:sp>
@@ -14338,7 +14242,7 @@
                 <a:ea typeface="Cambria" pitchFamily="34" charset="-122"/>
                 <a:cs typeface="Cambria" pitchFamily="34" charset="-120"/>
               </a:rPr>
-              <a:t>How We Track Progress</a:t>
+              <a:t>How We Check Progress</a:t>
             </a:r>
             <a:endParaRPr lang="en-US" sz="3200" dirty="0"/>
           </a:p>
@@ -14367,10 +14271,9 @@
             <a:tbl>
               <a:tblPr/>
               <a:tblGrid>
-                <a:gridCol w="2103120"/>
-                <a:gridCol w="1645920"/>
-                <a:gridCol w="2834640"/>
-                <a:gridCol w="1645920"/>
+                <a:gridCol w="2926080"/>
+                <a:gridCol w="2194560"/>
+                <a:gridCol w="3108960"/>
               </a:tblGrid>
               <a:tr h="338328">
                 <a:tc>
@@ -14382,14 +14285,14 @@
                         <a:buNone/>
                       </a:pPr>
                       <a:r>
-                        <a:rPr lang="en-US" sz="1300" b="1" dirty="0">
+                        <a:rPr lang="en-US" sz="1400" b="1" dirty="0">
                           <a:solidFill>
                             <a:schemeClr val="bg1"/>
                           </a:solidFill>
                         </a:rPr>
-                        <a:t>KPI</a:t>
+                        <a:t>What we check</a:t>
                       </a:r>
-                      <a:endParaRPr lang="en-US" sz="1300" dirty="0"/>
+                      <a:endParaRPr lang="en-US" sz="1400" dirty="0"/>
                     </a:p>
                   </a:txBody>
                   <a:tcPr marL="109728" marR="109728" marT="27432" marB="27432" anchor="ctr">
@@ -14419,14 +14322,14 @@
                         <a:buNone/>
                       </a:pPr>
                       <a:r>
-                        <a:rPr lang="en-US" sz="1300" b="1" dirty="0">
+                        <a:rPr lang="en-US" sz="1400" b="1" dirty="0">
                           <a:solidFill>
                             <a:schemeClr val="bg1"/>
                           </a:solidFill>
                         </a:rPr>
                         <a:t>Target</a:t>
                       </a:r>
-                      <a:endParaRPr lang="en-US" sz="1300" dirty="0"/>
+                      <a:endParaRPr lang="en-US" sz="1400" dirty="0"/>
                     </a:p>
                   </a:txBody>
                   <a:tcPr marL="109728" marR="109728" marT="27432" marB="27432" anchor="ctr">
@@ -14456,51 +14359,14 @@
                         <a:buNone/>
                       </a:pPr>
                       <a:r>
-                        <a:rPr lang="en-US" sz="1300" b="1" dirty="0">
+                        <a:rPr lang="en-US" sz="1400" b="1" dirty="0">
                           <a:solidFill>
                             <a:schemeClr val="bg1"/>
                           </a:solidFill>
                         </a:rPr>
-                        <a:t>How we check</a:t>
+                        <a:t>Where</a:t>
                       </a:r>
-                      <a:endParaRPr lang="en-US" sz="1300" dirty="0"/>
-                    </a:p>
-                  </a:txBody>
-                  <a:tcPr marL="109728" marR="109728" marT="27432" marB="27432" anchor="ctr">
-                    <a:lnL w="0" cap="flat" cmpd="sng" algn="ctr">
-                      <a:noFill/>
-                    </a:lnL>
-                    <a:lnR w="0" cap="flat" cmpd="sng" algn="ctr">
-                      <a:noFill/>
-                    </a:lnR>
-                    <a:lnT w="0" cap="flat" cmpd="sng" algn="ctr">
-                      <a:noFill/>
-                    </a:lnT>
-                    <a:lnB w="0" cap="flat" cmpd="sng" algn="ctr">
-                      <a:noFill/>
-                    </a:lnB>
-                    <a:solidFill>
-                      <a:schemeClr val="tx2"/>
-                    </a:solidFill>
-                  </a:tcPr>
-                </a:tc>
-                <a:tc>
-                  <a:txBody>
-                    <a:bodyPr/>
-                    <a:lstStyle/>
-                    <a:p>
-                      <a:pPr indent="0" marL="0">
-                        <a:buNone/>
-                      </a:pPr>
-                      <a:r>
-                        <a:rPr lang="en-US" sz="1300" b="1" dirty="0">
-                          <a:solidFill>
-                            <a:schemeClr val="bg1"/>
-                          </a:solidFill>
-                        </a:rPr>
-                        <a:t>How often</a:t>
-                      </a:r>
-                      <a:endParaRPr lang="en-US" sz="1300" dirty="0"/>
+                      <a:endParaRPr lang="en-US" sz="1400" dirty="0"/>
                     </a:p>
                   </a:txBody>
                   <a:tcPr marL="109728" marR="109728" marT="27432" marB="27432" anchor="ctr">
@@ -14532,14 +14398,14 @@
                         <a:buNone/>
                       </a:pPr>
                       <a:r>
-                        <a:rPr lang="en-US" sz="1300" b="1" dirty="0">
+                        <a:rPr lang="en-US" sz="1400" b="1" dirty="0">
                           <a:solidFill>
                             <a:schemeClr val="tx2"/>
                           </a:solidFill>
                         </a:rPr>
                         <a:t>Reach</a:t>
                       </a:r>
-                      <a:endParaRPr lang="en-US" sz="1300" dirty="0"/>
+                      <a:endParaRPr lang="en-US" sz="1400" dirty="0"/>
                     </a:p>
                   </a:txBody>
                   <a:tcPr marL="109728" marR="109728" marT="27432" marB="27432" anchor="ctr">
@@ -14569,14 +14435,14 @@
                         <a:buNone/>
                       </a:pPr>
                       <a:r>
-                        <a:rPr lang="en-US" sz="1300" b="1" dirty="0">
+                        <a:rPr lang="en-US" sz="1400" b="1" dirty="0">
                           <a:solidFill>
                             <a:schemeClr val="accent1"/>
                           </a:solidFill>
                         </a:rPr>
                         <a:t>40K+</a:t>
                       </a:r>
-                      <a:endParaRPr lang="en-US" sz="1300" dirty="0"/>
+                      <a:endParaRPr lang="en-US" sz="1400" dirty="0"/>
                     </a:p>
                   </a:txBody>
                   <a:tcPr marL="109728" marR="109728" marT="27432" marB="27432" anchor="ctr">
@@ -14606,51 +14472,14 @@
                         <a:buNone/>
                       </a:pPr>
                       <a:r>
-                        <a:rPr lang="en-US" sz="1300" dirty="0">
+                        <a:rPr lang="en-US" sz="1400" dirty="0">
                           <a:solidFill>
                             <a:schemeClr val="tx1"/>
                           </a:solidFill>
                         </a:rPr>
                         <a:t>Meta Ads Manager</a:t>
                       </a:r>
-                      <a:endParaRPr lang="en-US" sz="1300" dirty="0"/>
-                    </a:p>
-                  </a:txBody>
-                  <a:tcPr marL="109728" marR="109728" marT="27432" marB="27432" anchor="ctr">
-                    <a:lnL w="0" cap="flat" cmpd="sng" algn="ctr">
-                      <a:noFill/>
-                    </a:lnL>
-                    <a:lnR w="0" cap="flat" cmpd="sng" algn="ctr">
-                      <a:noFill/>
-                    </a:lnR>
-                    <a:lnT w="0" cap="flat" cmpd="sng" algn="ctr">
-                      <a:noFill/>
-                    </a:lnT>
-                    <a:lnB w="0" cap="flat" cmpd="sng" algn="ctr">
-                      <a:noFill/>
-                    </a:lnB>
-                    <a:solidFill>
-                      <a:schemeClr val="bg2"/>
-                    </a:solidFill>
-                  </a:tcPr>
-                </a:tc>
-                <a:tc>
-                  <a:txBody>
-                    <a:bodyPr/>
-                    <a:lstStyle/>
-                    <a:p>
-                      <a:pPr indent="0" marL="0">
-                        <a:buNone/>
-                      </a:pPr>
-                      <a:r>
-                        <a:rPr lang="en-US" sz="1300" dirty="0">
-                          <a:solidFill>
-                            <a:schemeClr val="tx1"/>
-                          </a:solidFill>
-                        </a:rPr>
-                        <a:t>Every week</a:t>
-                      </a:r>
-                      <a:endParaRPr lang="en-US" sz="1300" dirty="0"/>
+                      <a:endParaRPr lang="en-US" sz="1400" dirty="0"/>
                     </a:p>
                   </a:txBody>
                   <a:tcPr marL="109728" marR="109728" marT="27432" marB="27432" anchor="ctr">
@@ -14682,14 +14511,14 @@
                         <a:buNone/>
                       </a:pPr>
                       <a:r>
-                        <a:rPr lang="en-US" sz="1300" b="1" dirty="0">
+                        <a:rPr lang="en-US" sz="1400" b="1" dirty="0">
                           <a:solidFill>
                             <a:schemeClr val="tx2"/>
                           </a:solidFill>
                         </a:rPr>
-                        <a:t>New followers</a:t>
+                        <a:t>Followers</a:t>
                       </a:r>
-                      <a:endParaRPr lang="en-US" sz="1300" dirty="0"/>
+                      <a:endParaRPr lang="en-US" sz="1400" dirty="0"/>
                     </a:p>
                   </a:txBody>
                   <a:tcPr marL="109728" marR="109728" marT="27432" marB="27432" anchor="ctr">
@@ -14719,14 +14548,14 @@
                         <a:buNone/>
                       </a:pPr>
                       <a:r>
-                        <a:rPr lang="en-US" sz="1300" b="1" dirty="0">
+                        <a:rPr lang="en-US" sz="1400" b="1" dirty="0">
                           <a:solidFill>
                             <a:schemeClr val="accent1"/>
                           </a:solidFill>
                         </a:rPr>
                         <a:t>+500</a:t>
                       </a:r>
-                      <a:endParaRPr lang="en-US" sz="1300" dirty="0"/>
+                      <a:endParaRPr lang="en-US" sz="1400" dirty="0"/>
                     </a:p>
                   </a:txBody>
                   <a:tcPr marL="109728" marR="109728" marT="27432" marB="27432" anchor="ctr">
@@ -14756,51 +14585,14 @@
                         <a:buNone/>
                       </a:pPr>
                       <a:r>
-                        <a:rPr lang="en-US" sz="1300" dirty="0">
+                        <a:rPr lang="en-US" sz="1400" dirty="0">
                           <a:solidFill>
                             <a:schemeClr val="tx1"/>
                           </a:solidFill>
                         </a:rPr>
-                        <a:t>Instagram Insights</a:t>
+                        <a:t>Instagram</a:t>
                       </a:r>
-                      <a:endParaRPr lang="en-US" sz="1300" dirty="0"/>
-                    </a:p>
-                  </a:txBody>
-                  <a:tcPr marL="109728" marR="109728" marT="27432" marB="27432" anchor="ctr">
-                    <a:lnL w="0" cap="flat" cmpd="sng" algn="ctr">
-                      <a:noFill/>
-                    </a:lnL>
-                    <a:lnR w="0" cap="flat" cmpd="sng" algn="ctr">
-                      <a:noFill/>
-                    </a:lnR>
-                    <a:lnT w="0" cap="flat" cmpd="sng" algn="ctr">
-                      <a:noFill/>
-                    </a:lnT>
-                    <a:lnB w="0" cap="flat" cmpd="sng" algn="ctr">
-                      <a:noFill/>
-                    </a:lnB>
-                    <a:solidFill>
-                      <a:schemeClr val="bg1"/>
-                    </a:solidFill>
-                  </a:tcPr>
-                </a:tc>
-                <a:tc>
-                  <a:txBody>
-                    <a:bodyPr/>
-                    <a:lstStyle/>
-                    <a:p>
-                      <a:pPr indent="0" marL="0">
-                        <a:buNone/>
-                      </a:pPr>
-                      <a:r>
-                        <a:rPr lang="en-US" sz="1300" dirty="0">
-                          <a:solidFill>
-                            <a:schemeClr val="tx1"/>
-                          </a:solidFill>
-                        </a:rPr>
-                        <a:t>Every week</a:t>
-                      </a:r>
-                      <a:endParaRPr lang="en-US" sz="1300" dirty="0"/>
+                      <a:endParaRPr lang="en-US" sz="1400" dirty="0"/>
                     </a:p>
                   </a:txBody>
                   <a:tcPr marL="109728" marR="109728" marT="27432" marB="27432" anchor="ctr">
@@ -14832,14 +14624,14 @@
                         <a:buNone/>
                       </a:pPr>
                       <a:r>
-                        <a:rPr lang="en-US" sz="1300" b="1" dirty="0">
+                        <a:rPr lang="en-US" sz="1400" b="1" dirty="0">
                           <a:solidFill>
                             <a:schemeClr val="tx2"/>
                           </a:solidFill>
                         </a:rPr>
-                        <a:t>Inquiries</a:t>
+                        <a:t>Messages</a:t>
                       </a:r>
-                      <a:endParaRPr lang="en-US" sz="1300" dirty="0"/>
+                      <a:endParaRPr lang="en-US" sz="1400" dirty="0"/>
                     </a:p>
                   </a:txBody>
                   <a:tcPr marL="109728" marR="109728" marT="27432" marB="27432" anchor="ctr">
@@ -14869,14 +14661,14 @@
                         <a:buNone/>
                       </a:pPr>
                       <a:r>
-                        <a:rPr lang="en-US" sz="1300" b="1" dirty="0">
+                        <a:rPr lang="en-US" sz="1400" b="1" dirty="0">
                           <a:solidFill>
                             <a:schemeClr val="accent1"/>
                           </a:solidFill>
                         </a:rPr>
                         <a:t>100+</a:t>
                       </a:r>
-                      <a:endParaRPr lang="en-US" sz="1300" dirty="0"/>
+                      <a:endParaRPr lang="en-US" sz="1400" dirty="0"/>
                     </a:p>
                   </a:txBody>
                   <a:tcPr marL="109728" marR="109728" marT="27432" marB="27432" anchor="ctr">
@@ -14906,51 +14698,14 @@
                         <a:buNone/>
                       </a:pPr>
                       <a:r>
-                        <a:rPr lang="en-US" sz="1300" dirty="0">
+                        <a:rPr lang="en-US" sz="1400" dirty="0">
                           <a:solidFill>
                             <a:schemeClr val="tx1"/>
                           </a:solidFill>
                         </a:rPr>
-                        <a:t>Messages and calls log</a:t>
+                        <a:t>Inbox and calls</a:t>
                       </a:r>
-                      <a:endParaRPr lang="en-US" sz="1300" dirty="0"/>
-                    </a:p>
-                  </a:txBody>
-                  <a:tcPr marL="109728" marR="109728" marT="27432" marB="27432" anchor="ctr">
-                    <a:lnL w="0" cap="flat" cmpd="sng" algn="ctr">
-                      <a:noFill/>
-                    </a:lnL>
-                    <a:lnR w="0" cap="flat" cmpd="sng" algn="ctr">
-                      <a:noFill/>
-                    </a:lnR>
-                    <a:lnT w="0" cap="flat" cmpd="sng" algn="ctr">
-                      <a:noFill/>
-                    </a:lnT>
-                    <a:lnB w="0" cap="flat" cmpd="sng" algn="ctr">
-                      <a:noFill/>
-                    </a:lnB>
-                    <a:solidFill>
-                      <a:schemeClr val="bg2"/>
-                    </a:solidFill>
-                  </a:tcPr>
-                </a:tc>
-                <a:tc>
-                  <a:txBody>
-                    <a:bodyPr/>
-                    <a:lstStyle/>
-                    <a:p>
-                      <a:pPr indent="0" marL="0">
-                        <a:buNone/>
-                      </a:pPr>
-                      <a:r>
-                        <a:rPr lang="en-US" sz="1300" dirty="0">
-                          <a:solidFill>
-                            <a:schemeClr val="tx1"/>
-                          </a:solidFill>
-                        </a:rPr>
-                        <a:t>Every week</a:t>
-                      </a:r>
-                      <a:endParaRPr lang="en-US" sz="1300" dirty="0"/>
+                      <a:endParaRPr lang="en-US" sz="1400" dirty="0"/>
                     </a:p>
                   </a:txBody>
                   <a:tcPr marL="109728" marR="109728" marT="27432" marB="27432" anchor="ctr">
@@ -14982,14 +14737,14 @@
                         <a:buNone/>
                       </a:pPr>
                       <a:r>
-                        <a:rPr lang="en-US" sz="1300" b="1" dirty="0">
+                        <a:rPr lang="en-US" sz="1400" b="1" dirty="0">
                           <a:solidFill>
                             <a:schemeClr val="tx2"/>
                           </a:solidFill>
                         </a:rPr>
-                        <a:t>Cost per inquiry</a:t>
+                        <a:t>Cost per message</a:t>
                       </a:r>
-                      <a:endParaRPr lang="en-US" sz="1300" dirty="0"/>
+                      <a:endParaRPr lang="en-US" sz="1400" dirty="0"/>
                     </a:p>
                   </a:txBody>
                   <a:tcPr marL="109728" marR="109728" marT="27432" marB="27432" anchor="ctr">
@@ -15019,14 +14774,14 @@
                         <a:buNone/>
                       </a:pPr>
                       <a:r>
-                        <a:rPr lang="en-US" sz="1300" b="1" dirty="0">
+                        <a:rPr lang="en-US" sz="1400" b="1" dirty="0">
                           <a:solidFill>
                             <a:schemeClr val="accent1"/>
                           </a:solidFill>
                         </a:rPr>
                         <a:t>Under 40 EGP</a:t>
                       </a:r>
-                      <a:endParaRPr lang="en-US" sz="1300" dirty="0"/>
+                      <a:endParaRPr lang="en-US" sz="1400" dirty="0"/>
                     </a:p>
                   </a:txBody>
                   <a:tcPr marL="109728" marR="109728" marT="27432" marB="27432" anchor="ctr">
@@ -15056,51 +14811,14 @@
                         <a:buNone/>
                       </a:pPr>
                       <a:r>
-                        <a:rPr lang="en-US" sz="1300" dirty="0">
+                        <a:rPr lang="en-US" sz="1400" dirty="0">
                           <a:solidFill>
                             <a:schemeClr val="tx1"/>
                           </a:solidFill>
                         </a:rPr>
                         <a:t>Meta Ads Manager</a:t>
                       </a:r>
-                      <a:endParaRPr lang="en-US" sz="1300" dirty="0"/>
-                    </a:p>
-                  </a:txBody>
-                  <a:tcPr marL="109728" marR="109728" marT="27432" marB="27432" anchor="ctr">
-                    <a:lnL w="0" cap="flat" cmpd="sng" algn="ctr">
-                      <a:noFill/>
-                    </a:lnL>
-                    <a:lnR w="0" cap="flat" cmpd="sng" algn="ctr">
-                      <a:noFill/>
-                    </a:lnR>
-                    <a:lnT w="0" cap="flat" cmpd="sng" algn="ctr">
-                      <a:noFill/>
-                    </a:lnT>
-                    <a:lnB w="0" cap="flat" cmpd="sng" algn="ctr">
-                      <a:noFill/>
-                    </a:lnB>
-                    <a:solidFill>
-                      <a:schemeClr val="bg1"/>
-                    </a:solidFill>
-                  </a:tcPr>
-                </a:tc>
-                <a:tc>
-                  <a:txBody>
-                    <a:bodyPr/>
-                    <a:lstStyle/>
-                    <a:p>
-                      <a:pPr indent="0" marL="0">
-                        <a:buNone/>
-                      </a:pPr>
-                      <a:r>
-                        <a:rPr lang="en-US" sz="1300" dirty="0">
-                          <a:solidFill>
-                            <a:schemeClr val="tx1"/>
-                          </a:solidFill>
-                        </a:rPr>
-                        <a:t>Every week</a:t>
-                      </a:r>
-                      <a:endParaRPr lang="en-US" sz="1300" dirty="0"/>
+                      <a:endParaRPr lang="en-US" sz="1400" dirty="0"/>
                     </a:p>
                   </a:txBody>
                   <a:tcPr marL="109728" marR="109728" marT="27432" marB="27432" anchor="ctr">
@@ -15132,14 +14850,14 @@
                         <a:buNone/>
                       </a:pPr>
                       <a:r>
-                        <a:rPr lang="en-US" sz="1300" b="1" dirty="0">
+                        <a:rPr lang="en-US" sz="1400" b="1" dirty="0">
                           <a:solidFill>
                             <a:schemeClr val="tx2"/>
                           </a:solidFill>
                         </a:rPr>
-                        <a:t>Daily customers</a:t>
+                        <a:t>Customers</a:t>
                       </a:r>
-                      <a:endParaRPr lang="en-US" sz="1300" dirty="0"/>
+                      <a:endParaRPr lang="en-US" sz="1400" dirty="0"/>
                     </a:p>
                   </a:txBody>
                   <a:tcPr marL="109728" marR="109728" marT="27432" marB="27432" anchor="ctr">
@@ -15169,14 +14887,14 @@
                         <a:buNone/>
                       </a:pPr>
                       <a:r>
-                        <a:rPr lang="en-US" sz="1300" b="1" dirty="0">
+                        <a:rPr lang="en-US" sz="1400" b="1" dirty="0">
                           <a:solidFill>
                             <a:schemeClr val="accent1"/>
                           </a:solidFill>
                         </a:rPr>
-                        <a:t>+10</a:t>
+                        <a:t>+10 a day</a:t>
                       </a:r>
-                      <a:endParaRPr lang="en-US" sz="1300" dirty="0"/>
+                      <a:endParaRPr lang="en-US" sz="1400" dirty="0"/>
                     </a:p>
                   </a:txBody>
                   <a:tcPr marL="109728" marR="109728" marT="27432" marB="27432" anchor="ctr">
@@ -15206,51 +14924,14 @@
                         <a:buNone/>
                       </a:pPr>
                       <a:r>
-                        <a:rPr lang="en-US" sz="1300" dirty="0">
+                        <a:rPr lang="en-US" sz="1400" dirty="0">
                           <a:solidFill>
                             <a:schemeClr val="tx1"/>
                           </a:solidFill>
                         </a:rPr>
-                        <a:t>Café sales records</a:t>
+                        <a:t>Café sales</a:t>
                       </a:r>
-                      <a:endParaRPr lang="en-US" sz="1300" dirty="0"/>
-                    </a:p>
-                  </a:txBody>
-                  <a:tcPr marL="109728" marR="109728" marT="27432" marB="27432" anchor="ctr">
-                    <a:lnL w="0" cap="flat" cmpd="sng" algn="ctr">
-                      <a:noFill/>
-                    </a:lnL>
-                    <a:lnR w="0" cap="flat" cmpd="sng" algn="ctr">
-                      <a:noFill/>
-                    </a:lnR>
-                    <a:lnT w="0" cap="flat" cmpd="sng" algn="ctr">
-                      <a:noFill/>
-                    </a:lnT>
-                    <a:lnB w="0" cap="flat" cmpd="sng" algn="ctr">
-                      <a:noFill/>
-                    </a:lnB>
-                    <a:solidFill>
-                      <a:schemeClr val="bg2"/>
-                    </a:solidFill>
-                  </a:tcPr>
-                </a:tc>
-                <a:tc>
-                  <a:txBody>
-                    <a:bodyPr/>
-                    <a:lstStyle/>
-                    <a:p>
-                      <a:pPr indent="0" marL="0">
-                        <a:buNone/>
-                      </a:pPr>
-                      <a:r>
-                        <a:rPr lang="en-US" sz="1300" dirty="0">
-                          <a:solidFill>
-                            <a:schemeClr val="tx1"/>
-                          </a:solidFill>
-                        </a:rPr>
-                        <a:t>Every week</a:t>
-                      </a:r>
-                      <a:endParaRPr lang="en-US" sz="1300" dirty="0"/>
+                      <a:endParaRPr lang="en-US" sz="1400" dirty="0"/>
                     </a:p>
                   </a:txBody>
                   <a:tcPr marL="109728" marR="109728" marT="27432" marB="27432" anchor="ctr">
@@ -15381,12 +15062,12 @@
               <a:buNone/>
             </a:pPr>
             <a:r>
-              <a:rPr lang="en-US" sz="1200" dirty="0">
+              <a:rPr lang="en-US" sz="1300" dirty="0">
                 <a:solidFill>
                   <a:schemeClr val="tx1"/>
                 </a:solidFill>
               </a:rPr>
-              <a:t>Check ads, comments and messages</a:t>
+              <a:t>Check ads and comments</a:t>
             </a:r>
             <a:endParaRPr lang="en-US" sz="1400" dirty="0"/>
           </a:p>
@@ -15497,12 +15178,12 @@
               <a:buNone/>
             </a:pPr>
             <a:r>
-              <a:rPr lang="en-US" sz="1200" dirty="0">
+              <a:rPr lang="en-US" sz="1300" dirty="0">
                 <a:solidFill>
                   <a:schemeClr val="tx1"/>
                 </a:solidFill>
               </a:rPr>
-              <a:t>Progress report to the owner</a:t>
+              <a:t>Report to the owner</a:t>
             </a:r>
             <a:endParaRPr lang="en-US" sz="1400" dirty="0"/>
           </a:p>
@@ -15532,7 +15213,7 @@
       </p:sp>
       <p:sp>
         <p:nvSpPr>
-          <p:cNvPr id="14" name="End of week 4 circle"/>
+          <p:cNvPr id="14" name="Week 4 circle"/>
           <p:cNvSpPr/>
           <p:nvPr/>
         </p:nvSpPr>
@@ -15552,7 +15233,7 @@
       </p:sp>
       <p:pic>
         <p:nvPicPr>
-          <p:cNvPr id="15" name="End of week 4 icon" descr="End of week 4">    </p:cNvPr>
+          <p:cNvPr id="15" name="Week 4 icon" descr="Week 4">    </p:cNvPr>
           <p:cNvPicPr>
             <a:picLocks noChangeAspect="1"/>
           </p:cNvPicPr>
@@ -15604,7 +15285,7 @@
                   <a:schemeClr val="tx2"/>
                 </a:solidFill>
               </a:rPr>
-              <a:t>End of week 4</a:t>
+              <a:t>Week 4</a:t>
             </a:r>
             <a:endParaRPr lang="en-US" sz="1400" dirty="0"/>
           </a:p>
@@ -15613,12 +15294,12 @@
               <a:buNone/>
             </a:pPr>
             <a:r>
-              <a:rPr lang="en-US" sz="1200" dirty="0">
+              <a:rPr lang="en-US" sz="1300" dirty="0">
                 <a:solidFill>
                   <a:schemeClr val="tx1"/>
                 </a:solidFill>
               </a:rPr>
-              <a:t>Full results review</a:t>
+              <a:t>Final review</a:t>
             </a:r>
             <a:endParaRPr lang="en-US" sz="1400" dirty="0"/>
           </a:p>
@@ -15767,7 +15448,7 @@
                 <a:ea typeface="Cambria" pitchFamily="34" charset="-122"/>
                 <a:cs typeface="Cambria" pitchFamily="34" charset="-120"/>
               </a:rPr>
-              <a:t>When the Numbers Talk, We Act</a:t>
+              <a:t>If Something Is Weak, We Fix It</a:t>
             </a:r>
             <a:endParaRPr lang="en-US" sz="3200" dirty="0"/>
           </a:p>
@@ -15797,7 +15478,7 @@
       </p:sp>
       <p:sp>
         <p:nvSpPr>
-          <p:cNvPr id="5" name="Reach is below target circle"/>
+          <p:cNvPr id="5" name="Few people see us circle"/>
           <p:cNvSpPr/>
           <p:nvPr/>
         </p:nvSpPr>
@@ -15817,7 +15498,7 @@
       </p:sp>
       <p:pic>
         <p:nvPicPr>
-          <p:cNvPr id="6" name="Reach is below target icon" descr="Reach is below target">    </p:cNvPr>
+          <p:cNvPr id="6" name="Few people see us icon" descr="Few people see us">    </p:cNvPr>
           <p:cNvPicPr>
             <a:picLocks noChangeAspect="1"/>
           </p:cNvPicPr>
@@ -15881,12 +15562,12 @@
               <a:buNone/>
             </a:pPr>
             <a:r>
-              <a:rPr lang="en-US" sz="1400" b="1" dirty="0">
+              <a:rPr lang="en-US" sz="1500" b="1" dirty="0">
                 <a:solidFill>
                   <a:schemeClr val="tx2"/>
                 </a:solidFill>
               </a:rPr>
-              <a:t>Reach is below target</a:t>
+              <a:t>Few people see us</a:t>
             </a:r>
             <a:endParaRPr lang="en-US" sz="1100" dirty="0"/>
           </a:p>
@@ -15912,12 +15593,12 @@
               <a:buNone/>
             </a:pPr>
             <a:r>
-              <a:rPr lang="en-US" sz="1300" dirty="0">
+              <a:rPr lang="en-US" sz="1400" dirty="0">
                 <a:solidFill>
                   <a:schemeClr val="tx1"/>
                 </a:solidFill>
               </a:rPr>
-              <a:t>Move the budget to the best-performing ad</a:t>
+              <a:t>Put more money in the best ad</a:t>
             </a:r>
             <a:endParaRPr lang="en-US" sz="1100" dirty="0"/>
           </a:p>
@@ -15947,7 +15628,7 @@
       </p:sp>
       <p:sp>
         <p:nvSpPr>
-          <p:cNvPr id="9" name="Few likes and comments circle"/>
+          <p:cNvPr id="9" name="Few likes circle"/>
           <p:cNvSpPr/>
           <p:nvPr/>
         </p:nvSpPr>
@@ -15967,7 +15648,7 @@
       </p:sp>
       <p:pic>
         <p:nvPicPr>
-          <p:cNvPr id="10" name="Few likes and comments icon" descr="Few likes and comments">    </p:cNvPr>
+          <p:cNvPr id="10" name="Few likes icon" descr="Few likes">    </p:cNvPr>
           <p:cNvPicPr>
             <a:picLocks noChangeAspect="1"/>
           </p:cNvPicPr>
@@ -16031,12 +15712,12 @@
               <a:buNone/>
             </a:pPr>
             <a:r>
-              <a:rPr lang="en-US" sz="1400" b="1" dirty="0">
+              <a:rPr lang="en-US" sz="1500" b="1" dirty="0">
                 <a:solidFill>
                   <a:schemeClr val="tx2"/>
                 </a:solidFill>
               </a:rPr>
-              <a:t>Few likes and comments</a:t>
+              <a:t>Few likes</a:t>
             </a:r>
             <a:endParaRPr lang="en-US" sz="1100" dirty="0"/>
           </a:p>
@@ -16062,12 +15743,12 @@
               <a:buNone/>
             </a:pPr>
             <a:r>
-              <a:rPr lang="en-US" sz="1300" dirty="0">
+              <a:rPr lang="en-US" sz="1400" dirty="0">
                 <a:solidFill>
                   <a:schemeClr val="tx1"/>
                 </a:solidFill>
               </a:rPr>
-              <a:t>Post more reels and test new posting times</a:t>
+              <a:t>More reels, new post times</a:t>
             </a:r>
             <a:endParaRPr lang="en-US" sz="1100" dirty="0"/>
           </a:p>
@@ -16097,7 +15778,7 @@
       </p:sp>
       <p:sp>
         <p:nvSpPr>
-          <p:cNvPr id="13" name="Many views, few messages circle"/>
+          <p:cNvPr id="13" name="Views but no messages circle"/>
           <p:cNvSpPr/>
           <p:nvPr/>
         </p:nvSpPr>
@@ -16117,7 +15798,7 @@
       </p:sp>
       <p:pic>
         <p:nvPicPr>
-          <p:cNvPr id="14" name="Many views, few messages icon" descr="Many views, few messages">    </p:cNvPr>
+          <p:cNvPr id="14" name="Views but no messages icon" descr="Views but no messages">    </p:cNvPr>
           <p:cNvPicPr>
             <a:picLocks noChangeAspect="1"/>
           </p:cNvPicPr>
@@ -16181,12 +15862,12 @@
               <a:buNone/>
             </a:pPr>
             <a:r>
-              <a:rPr lang="en-US" sz="1400" b="1" dirty="0">
+              <a:rPr lang="en-US" sz="1500" b="1" dirty="0">
                 <a:solidFill>
                   <a:schemeClr val="tx2"/>
                 </a:solidFill>
               </a:rPr>
-              <a:t>Many views, few messages</a:t>
+              <a:t>Views but no messages</a:t>
             </a:r>
             <a:endParaRPr lang="en-US" sz="1100" dirty="0"/>
           </a:p>
@@ -16212,12 +15893,12 @@
               <a:buNone/>
             </a:pPr>
             <a:r>
-              <a:rPr lang="en-US" sz="1300" dirty="0">
+              <a:rPr lang="en-US" sz="1400" dirty="0">
                 <a:solidFill>
                   <a:schemeClr val="tx1"/>
                 </a:solidFill>
               </a:rPr>
-              <a:t>Add a clearer offer and call to action</a:t>
+              <a:t>Add a clear offer</a:t>
             </a:r>
             <a:endParaRPr lang="en-US" sz="1100" dirty="0"/>
           </a:p>
@@ -16247,7 +15928,7 @@
       </p:sp>
       <p:sp>
         <p:nvSpPr>
-          <p:cNvPr id="17" name="Few new visits circle"/>
+          <p:cNvPr id="17" name="Few new customers circle"/>
           <p:cNvSpPr/>
           <p:nvPr/>
         </p:nvSpPr>
@@ -16267,7 +15948,7 @@
       </p:sp>
       <p:pic>
         <p:nvPicPr>
-          <p:cNvPr id="18" name="Few new visits icon" descr="Few new visits">    </p:cNvPr>
+          <p:cNvPr id="18" name="Few new customers icon" descr="Few new customers">    </p:cNvPr>
           <p:cNvPicPr>
             <a:picLocks noChangeAspect="1"/>
           </p:cNvPicPr>
@@ -16331,12 +16012,12 @@
               <a:buNone/>
             </a:pPr>
             <a:r>
-              <a:rPr lang="en-US" sz="1400" b="1" dirty="0">
+              <a:rPr lang="en-US" sz="1500" b="1" dirty="0">
                 <a:solidFill>
                   <a:schemeClr val="tx2"/>
                 </a:solidFill>
               </a:rPr>
-              <a:t>Few new visits</a:t>
+              <a:t>Few new customers</a:t>
             </a:r>
             <a:endParaRPr lang="en-US" sz="1100" dirty="0"/>
           </a:p>
@@ -16362,12 +16043,12 @@
               <a:buNone/>
             </a:pPr>
             <a:r>
-              <a:rPr lang="en-US" sz="1300" dirty="0">
+              <a:rPr lang="en-US" sz="1400" dirty="0">
                 <a:solidFill>
                   <a:schemeClr val="tx1"/>
                 </a:solidFill>
               </a:rPr>
-              <a:t>Stronger offer, target people closer to the café</a:t>
+              <a:t>Better offer, target nearby people</a:t>
             </a:r>
             <a:endParaRPr lang="en-US" sz="1100" dirty="0"/>
           </a:p>
@@ -16480,7 +16161,7 @@
                   <a:schemeClr val="bg1"/>
                 </a:solidFill>
               </a:rPr>
-              <a:t>we review everything with the owner and plan month two</a:t>
+              <a:t>we meet the owner and plan month two</a:t>
             </a:r>
             <a:endParaRPr lang="en-US" sz="1500" dirty="0"/>
           </a:p>

</xml_diff>